<commit_message>
DP5 slides: regroup module views by Decision / Control / Data Transfer plane
Co-Authored-By: Claude Sonnet 5.5 <noreply@anthropic.com>
Claude-Session: https://claude.ai/code/session_01AuCqbPk6deqqdKjH41c27g
</commit_message>
<xml_diff>
--- a/doc-mk/DP5/DP1_DP5_full_module_view.pptx
+++ b/doc-mk/DP5/DP1_DP5_full_module_view.pptx
@@ -8,7 +8,7 @@
     <p:notesMasterId r:id="rId49"/>
   </p:notesMasterIdLst>
   <p:sldIdLst>
-    <p:sldId id="698" r:id="rId54"/>
+    <p:sldId id="701" r:id="rId57"/>
   </p:sldIdLst>
   <p:sldSz cx="12192000" cy="6858000"/>
   <p:notesSz cx="6858000" cy="9144000"/>
@@ -5077,7 +5077,7 @@
 </p:sldMaster>
 </file>
 
-<file path=ppt/slides/slide48.xml><?xml version="1.0" encoding="utf-8"?>
+<file path=ppt/slides/slide51.xml><?xml version="1.0" encoding="utf-8"?>
 <p:sld xmlns:a="http://schemas.openxmlformats.org/drawingml/2006/main" xmlns:r="http://schemas.openxmlformats.org/officeDocument/2006/relationships" xmlns:p="http://schemas.openxmlformats.org/presentationml/2006/main">
   <p:cSld>
     <p:spTree>
@@ -5117,7 +5117,7 @@
           <a:p>
             <a:r>
               <a:rPr lang="en-US" altLang="ko-KR" dirty="0"/>
-              <a:t>Architecture 분석 – DP-1 ~ DP-5 전체 Module View (후보 1 기준)</a:t>
+              <a:t>DP5. 전체 Module View - 3 Plane 구조 (후보 1)</a:t>
             </a:r>
             <a:endParaRPr lang="ko-KR" altLang="en-US" dirty="0"/>
           </a:p>
@@ -5131,7 +5131,7 @@
         </p:nvSpPr>
         <p:spPr>
           <a:xfrm>
-            <a:off x="400000" y="620000"/>
+            <a:off x="400000" y="600000"/>
             <a:ext cx="11400000" cy="200000"/>
           </a:xfrm>
           <a:prstGeom prst="rect">
@@ -5152,31 +5152,29 @@
                   <a:schemeClr val="tx1"/>
                 </a:solidFill>
               </a:rPr>
-              <a:t>노란색: 신규/수정 모듈  ·  점선 박스: 설계 범위 (빨강 DP-1, 주황 DP-5)  ·  굵은 화살표: DP 간 · 프로세스 간 경계  ·  후보 2는 Data Location Store와 commit이 Worker 쪽으로 이동</a:t>
-            </a:r>
-          </a:p>
-        </p:txBody>
-      </p:sp>
-      <p:sp>
-        <p:nvSpPr>
-          <p:cNvPr id="102" name="EngineCore"/>
+              <a:t>Decision = 무엇을·언제·어디로 (정책)  ·  Control = 이동 lifecycle·위치 권한 (상태·조율)  ·  Data Transfer = 복사 실행   |   노랑: 신규·수정, 회색: 기존, 점선: 설계 범위 (빨강 DP-1, 주황 DP-5), 굵은 화살표: plane·프로세스 경계</a:t>
+            </a:r>
+          </a:p>
+        </p:txBody>
+      </p:sp>
+      <p:sp>
+        <p:nvSpPr>
+          <p:cNvPr id="102" name="proc EC"/>
           <p:cNvSpPr/>
           <p:nvPr/>
         </p:nvSpPr>
         <p:spPr>
           <a:xfrm>
-            <a:off x="400000" y="950000"/>
-            <a:ext cx="7550000" cy="4550000"/>
+            <a:off x="400000" y="860000"/>
+            <a:ext cx="7650000" cy="220000"/>
           </a:xfrm>
           <a:prstGeom prst="rect">
             <a:avLst/>
           </a:prstGeom>
           <a:solidFill>
-            <a:schemeClr val="bg1">
-              <a:lumMod val="95000"/>
-            </a:schemeClr>
+            <a:srgbClr val="D9D9D9"/>
           </a:solidFill>
-          <a:ln w="28575">
+          <a:ln w="19050">
             <a:solidFill>
               <a:schemeClr val="tx1"/>
             </a:solidFill>
@@ -5199,12 +5197,14 @@
           </a:fontRef>
         </p:style>
         <p:txBody>
-          <a:bodyPr rtlCol="0" anchor="t"/>
+          <a:bodyPr lIns="0" tIns="0" rIns="0" bIns="0" rtlCol="0" anchor="ctr">
+            <a:noAutofit/>
+          </a:bodyPr>
           <a:lstStyle/>
           <a:p>
             <a:pPr algn="ctr"/>
             <a:r>
-              <a:rPr lang="ko-KR" altLang="en-US" sz="1100" b="1" dirty="0">
+              <a:rPr lang="ko-KR" altLang="en-US" sz="900" b="1" dirty="0">
                 <a:solidFill>
                   <a:schemeClr val="tx1"/>
                 </a:solidFill>
@@ -5216,24 +5216,22 @@
       </p:sp>
       <p:sp>
         <p:nvSpPr>
-          <p:cNvPr id="103" name="Worker"/>
+          <p:cNvPr id="103" name="proc W"/>
           <p:cNvSpPr/>
           <p:nvPr/>
         </p:nvSpPr>
         <p:spPr>
           <a:xfrm>
-            <a:off x="8650000" y="950000"/>
-            <a:ext cx="3150000" cy="4550000"/>
+            <a:off x="8750000" y="860000"/>
+            <a:ext cx="3050000" cy="220000"/>
           </a:xfrm>
           <a:prstGeom prst="rect">
             <a:avLst/>
           </a:prstGeom>
           <a:solidFill>
-            <a:schemeClr val="bg1">
-              <a:lumMod val="95000"/>
-            </a:schemeClr>
+            <a:srgbClr val="D9D9D9"/>
           </a:solidFill>
-          <a:ln w="28575">
+          <a:ln w="19050">
             <a:solidFill>
               <a:schemeClr val="tx1"/>
             </a:solidFill>
@@ -5256,12 +5254,14 @@
           </a:fontRef>
         </p:style>
         <p:txBody>
-          <a:bodyPr rtlCol="0" anchor="t"/>
+          <a:bodyPr lIns="0" tIns="0" rIns="0" bIns="0" rtlCol="0" anchor="ctr">
+            <a:noAutofit/>
+          </a:bodyPr>
           <a:lstStyle/>
           <a:p>
             <a:pPr algn="ctr"/>
             <a:r>
-              <a:rPr lang="ko-KR" altLang="en-US" sz="1100" b="1" dirty="0">
+              <a:rPr lang="ko-KR" altLang="en-US" sz="900" b="1" dirty="0">
                 <a:solidFill>
                   <a:schemeClr val="tx1"/>
                 </a:solidFill>
@@ -5279,8 +5279,8 @@
         </p:nvSpPr>
         <p:spPr>
           <a:xfrm>
-            <a:off x="550000" y="1450000"/>
-            <a:ext cx="7300000" cy="750000"/>
+            <a:off x="400000" y="1320000"/>
+            <a:ext cx="7650000" cy="700000"/>
           </a:xfrm>
           <a:prstGeom prst="rect">
             <a:avLst/>
@@ -5314,7 +5314,9 @@
           </a:fontRef>
         </p:style>
         <p:txBody>
-          <a:bodyPr rtlCol="0" anchor="t"/>
+          <a:bodyPr lIns="36000" tIns="18000" rIns="36000" bIns="0" rtlCol="0" anchor="t">
+            <a:noAutofit/>
+          </a:bodyPr>
           <a:lstStyle/>
           <a:p>
             <a:pPr algn="ctr"/>
@@ -5337,7 +5339,7 @@
         </p:nvSpPr>
         <p:spPr>
           <a:xfrm>
-            <a:off x="550000" y="1320000"/>
+            <a:off x="400000" y="1190000"/>
             <a:ext cx="264000" cy="131000"/>
           </a:xfrm>
           <a:prstGeom prst="rect">
@@ -5372,10 +5374,12 @@
           </a:fontRef>
         </p:style>
         <p:txBody>
-          <a:bodyPr rtlCol="0" anchor="ctr"/>
-          <a:lstStyle/>
-          <a:p>
-            <a:endParaRPr lang="ko-KR" altLang="en-US"/>
+          <a:bodyPr lIns="36000" tIns="18000" rIns="36000" bIns="18000" rtlCol="0" anchor="ctr">
+            <a:noAutofit/>
+          </a:bodyPr>
+          <a:lstStyle/>
+          <a:p>
+            <a:endParaRPr lang="ko-KR"/>
           </a:p>
         </p:txBody>
       </p:sp>
@@ -5387,8 +5391,126 @@
         </p:nvSpPr>
         <p:spPr>
           <a:xfrm>
-            <a:off x="650000" y="1800000"/>
-            <a:ext cx="1550000" cy="340000"/>
+            <a:off x="550000" y="1660000"/>
+            <a:ext cx="1550000" cy="300000"/>
+          </a:xfrm>
+          <a:prstGeom prst="rect">
+            <a:avLst/>
+          </a:prstGeom>
+          <a:solidFill>
+            <a:schemeClr val="bg1">
+              <a:lumMod val="95000"/>
+            </a:schemeClr>
+          </a:solidFill>
+          <a:ln w="12700">
+            <a:solidFill>
+              <a:schemeClr val="tx1"/>
+            </a:solidFill>
+          </a:ln>
+        </p:spPr>
+        <p:style>
+          <a:lnRef idx="2">
+            <a:schemeClr val="accent1">
+              <a:shade val="50000"/>
+            </a:schemeClr>
+          </a:lnRef>
+          <a:fillRef idx="1">
+            <a:schemeClr val="accent1"/>
+          </a:fillRef>
+          <a:effectRef idx="0">
+            <a:schemeClr val="accent1"/>
+          </a:effectRef>
+          <a:fontRef idx="minor">
+            <a:schemeClr val="lt1"/>
+          </a:fontRef>
+        </p:style>
+        <p:txBody>
+          <a:bodyPr lIns="36000" tIns="18000" rIns="36000" bIns="18000" rtlCol="0" anchor="ctr">
+            <a:noAutofit/>
+          </a:bodyPr>
+          <a:lstStyle/>
+          <a:p>
+            <a:pPr algn="ctr"/>
+            <a:r>
+              <a:rPr lang="ko-KR" altLang="en-US" sz="900" b="1" dirty="0">
+                <a:solidFill>
+                  <a:schemeClr val="tx1"/>
+                </a:solidFill>
+              </a:rPr>
+              <a:t>KV Cache Manager</a:t>
+            </a:r>
+          </a:p>
+        </p:txBody>
+      </p:sp>
+      <p:sp>
+        <p:nvSpPr>
+          <p:cNvPr id="107" name="KVDataAdapter"/>
+          <p:cNvSpPr/>
+          <p:nvPr/>
+        </p:nvSpPr>
+        <p:spPr>
+          <a:xfrm>
+            <a:off x="2300000" y="1660000"/>
+            <a:ext cx="1550000" cy="300000"/>
+          </a:xfrm>
+          <a:prstGeom prst="rect">
+            <a:avLst/>
+          </a:prstGeom>
+          <a:solidFill>
+            <a:schemeClr val="bg1">
+              <a:lumMod val="95000"/>
+            </a:schemeClr>
+          </a:solidFill>
+          <a:ln w="12700">
+            <a:solidFill>
+              <a:schemeClr val="tx1"/>
+            </a:solidFill>
+          </a:ln>
+        </p:spPr>
+        <p:style>
+          <a:lnRef idx="2">
+            <a:schemeClr val="accent1">
+              <a:shade val="50000"/>
+            </a:schemeClr>
+          </a:lnRef>
+          <a:fillRef idx="1">
+            <a:schemeClr val="accent1"/>
+          </a:fillRef>
+          <a:effectRef idx="0">
+            <a:schemeClr val="accent1"/>
+          </a:effectRef>
+          <a:fontRef idx="minor">
+            <a:schemeClr val="lt1"/>
+          </a:fontRef>
+        </p:style>
+        <p:txBody>
+          <a:bodyPr lIns="36000" tIns="18000" rIns="36000" bIns="18000" rtlCol="0" anchor="ctr">
+            <a:noAutofit/>
+          </a:bodyPr>
+          <a:lstStyle/>
+          <a:p>
+            <a:pPr algn="ctr"/>
+            <a:r>
+              <a:rPr lang="ko-KR" altLang="en-US" sz="900" b="1" dirty="0">
+                <a:solidFill>
+                  <a:schemeClr val="tx1"/>
+                </a:solidFill>
+              </a:rPr>
+              <a:t>KVDataAdapter</a:t>
+            </a:r>
+          </a:p>
+        </p:txBody>
+      </p:sp>
+      <p:sp>
+        <p:nvSpPr>
+          <p:cNvPr id="108" name="Scheduler"/>
+          <p:cNvSpPr/>
+          <p:nvPr/>
+        </p:nvSpPr>
+        <p:spPr>
+          <a:xfrm>
+            <a:off x="6500000" y="1660000"/>
+            <a:ext cx="1450000" cy="300000"/>
           </a:xfrm>
           <a:prstGeom prst="rect">
             <a:avLst/>
@@ -5399,128 +5521,32 @@
               <a:lumOff val="80000"/>
             </a:schemeClr>
           </a:solidFill>
-          <a:ln/>
+          <a:ln w="12700">
+            <a:solidFill>
+              <a:schemeClr val="tx1"/>
+            </a:solidFill>
+          </a:ln>
         </p:spPr>
         <p:style>
           <a:lnRef idx="2">
-            <a:schemeClr val="dk1"/>
+            <a:schemeClr val="accent1">
+              <a:shade val="50000"/>
+            </a:schemeClr>
           </a:lnRef>
           <a:fillRef idx="1">
-            <a:schemeClr val="lt1"/>
+            <a:schemeClr val="accent1"/>
           </a:fillRef>
           <a:effectRef idx="0">
-            <a:schemeClr val="dk1"/>
+            <a:schemeClr val="accent1"/>
           </a:effectRef>
           <a:fontRef idx="minor">
-            <a:schemeClr val="dk1"/>
+            <a:schemeClr val="lt1"/>
           </a:fontRef>
         </p:style>
         <p:txBody>
-          <a:bodyPr lIns="36000" rIns="36000" tIns="18000" bIns="18000" rtlCol="0" anchor="ctr"/>
-          <a:lstStyle/>
-          <a:p>
-            <a:pPr algn="ctr"/>
-            <a:r>
-              <a:rPr lang="ko-KR" altLang="en-US" sz="900" b="1" dirty="0">
-                <a:solidFill>
-                  <a:schemeClr val="tx1"/>
-                </a:solidFill>
-              </a:rPr>
-              <a:t>KV Cache Manager</a:t>
-            </a:r>
-          </a:p>
-        </p:txBody>
-      </p:sp>
-      <p:sp>
-        <p:nvSpPr>
-          <p:cNvPr id="107" name="KVDataAdapter"/>
-          <p:cNvSpPr/>
-          <p:nvPr/>
-        </p:nvSpPr>
-        <p:spPr>
-          <a:xfrm>
-            <a:off x="2350000" y="1800000"/>
-            <a:ext cx="1550000" cy="340000"/>
-          </a:xfrm>
-          <a:prstGeom prst="rect">
-            <a:avLst/>
-          </a:prstGeom>
-          <a:solidFill>
-            <a:schemeClr val="accent4">
-              <a:lumMod val="20000"/>
-              <a:lumOff val="80000"/>
-            </a:schemeClr>
-          </a:solidFill>
-          <a:ln/>
-        </p:spPr>
-        <p:style>
-          <a:lnRef idx="2">
-            <a:schemeClr val="dk1"/>
-          </a:lnRef>
-          <a:fillRef idx="1">
-            <a:schemeClr val="lt1"/>
-          </a:fillRef>
-          <a:effectRef idx="0">
-            <a:schemeClr val="dk1"/>
-          </a:effectRef>
-          <a:fontRef idx="minor">
-            <a:schemeClr val="dk1"/>
-          </a:fontRef>
-        </p:style>
-        <p:txBody>
-          <a:bodyPr lIns="36000" rIns="36000" tIns="18000" bIns="18000" rtlCol="0" anchor="ctr"/>
-          <a:lstStyle/>
-          <a:p>
-            <a:pPr algn="ctr"/>
-            <a:r>
-              <a:rPr lang="ko-KR" altLang="en-US" sz="900" b="1" dirty="0">
-                <a:solidFill>
-                  <a:schemeClr val="tx1"/>
-                </a:solidFill>
-              </a:rPr>
-              <a:t>KVDataAdapter</a:t>
-            </a:r>
-          </a:p>
-        </p:txBody>
-      </p:sp>
-      <p:sp>
-        <p:nvSpPr>
-          <p:cNvPr id="108" name="Scheduler"/>
-          <p:cNvSpPr/>
-          <p:nvPr/>
-        </p:nvSpPr>
-        <p:spPr>
-          <a:xfrm>
-            <a:off x="5030000" y="1800000"/>
-            <a:ext cx="1250000" cy="340000"/>
-          </a:xfrm>
-          <a:prstGeom prst="rect">
-            <a:avLst/>
-          </a:prstGeom>
-          <a:solidFill>
-            <a:schemeClr val="accent4">
-              <a:lumMod val="20000"/>
-              <a:lumOff val="80000"/>
-            </a:schemeClr>
-          </a:solidFill>
-          <a:ln/>
-        </p:spPr>
-        <p:style>
-          <a:lnRef idx="2">
-            <a:schemeClr val="dk1"/>
-          </a:lnRef>
-          <a:fillRef idx="1">
-            <a:schemeClr val="lt1"/>
-          </a:fillRef>
-          <a:effectRef idx="0">
-            <a:schemeClr val="dk1"/>
-          </a:effectRef>
-          <a:fontRef idx="minor">
-            <a:schemeClr val="dk1"/>
-          </a:fontRef>
-        </p:style>
-        <p:txBody>
-          <a:bodyPr lIns="36000" rIns="36000" tIns="18000" bIns="18000" rtlCol="0" anchor="ctr"/>
+          <a:bodyPr lIns="36000" tIns="18000" rIns="36000" bIns="18000" rtlCol="0" anchor="ctr">
+            <a:noAutofit/>
+          </a:bodyPr>
           <a:lstStyle/>
           <a:p>
             <a:pPr algn="ctr"/>
@@ -5537,14 +5563,14 @@
       </p:sp>
       <p:sp>
         <p:nvSpPr>
-          <p:cNvPr id="109" name="DecisionPlane"/>
+          <p:cNvPr id="109" name="Compute"/>
           <p:cNvSpPr/>
           <p:nvPr/>
         </p:nvSpPr>
         <p:spPr>
           <a:xfrm>
-            <a:off x="550000" y="2500000"/>
-            <a:ext cx="3350000" cy="2900000"/>
+            <a:off x="8750000" y="1320000"/>
+            <a:ext cx="3050000" cy="700000"/>
           </a:xfrm>
           <a:prstGeom prst="rect">
             <a:avLst/>
@@ -5578,7 +5604,9 @@
           </a:fontRef>
         </p:style>
         <p:txBody>
-          <a:bodyPr rtlCol="0" anchor="t"/>
+          <a:bodyPr lIns="36000" tIns="18000" rIns="36000" bIns="0" rtlCol="0" anchor="t">
+            <a:noAutofit/>
+          </a:bodyPr>
           <a:lstStyle/>
           <a:p>
             <a:pPr algn="ctr"/>
@@ -5588,20 +5616,20 @@
                   <a:schemeClr val="tx1"/>
                 </a:solidFill>
               </a:rPr>
-              <a:t>Decision Plane · DP-1 (정책)</a:t>
-            </a:r>
-          </a:p>
-        </p:txBody>
-      </p:sp>
-      <p:sp>
-        <p:nvSpPr>
-          <p:cNvPr id="110" name="DecisionPlane tab"/>
+              <a:t>Compute Management (기존)</a:t>
+            </a:r>
+          </a:p>
+        </p:txBody>
+      </p:sp>
+      <p:sp>
+        <p:nvSpPr>
+          <p:cNvPr id="110" name="Compute tab"/>
           <p:cNvSpPr/>
           <p:nvPr/>
         </p:nvSpPr>
         <p:spPr>
           <a:xfrm>
-            <a:off x="550000" y="2370000"/>
+            <a:off x="8750000" y="1190000"/>
             <a:ext cx="264000" cy="131000"/>
           </a:xfrm>
           <a:prstGeom prst="rect">
@@ -5636,23 +5664,84 @@
           </a:fontRef>
         </p:style>
         <p:txBody>
-          <a:bodyPr rtlCol="0" anchor="ctr"/>
-          <a:lstStyle/>
-          <a:p>
-            <a:endParaRPr lang="ko-KR" altLang="en-US"/>
-          </a:p>
-        </p:txBody>
-      </p:sp>
-      <p:sp>
-        <p:nvSpPr>
-          <p:cNvPr id="111" name="Migration Scheduler"/>
+          <a:bodyPr lIns="36000" tIns="18000" rIns="36000" bIns="18000" rtlCol="0" anchor="ctr">
+            <a:noAutofit/>
+          </a:bodyPr>
+          <a:lstStyle/>
+          <a:p>
+            <a:endParaRPr lang="ko-KR"/>
+          </a:p>
+        </p:txBody>
+      </p:sp>
+      <p:sp>
+        <p:nvSpPr>
+          <p:cNvPr id="111" name="Worker"/>
           <p:cNvSpPr/>
           <p:nvPr/>
         </p:nvSpPr>
         <p:spPr>
           <a:xfrm>
-            <a:off x="650000" y="2900000"/>
-            <a:ext cx="1450000" cy="360000"/>
+            <a:off x="8850000" y="1660000"/>
+            <a:ext cx="900000" cy="300000"/>
+          </a:xfrm>
+          <a:prstGeom prst="rect">
+            <a:avLst/>
+          </a:prstGeom>
+          <a:solidFill>
+            <a:schemeClr val="bg1">
+              <a:lumMod val="95000"/>
+            </a:schemeClr>
+          </a:solidFill>
+          <a:ln w="12700">
+            <a:solidFill>
+              <a:schemeClr val="tx1"/>
+            </a:solidFill>
+          </a:ln>
+        </p:spPr>
+        <p:style>
+          <a:lnRef idx="2">
+            <a:schemeClr val="accent1">
+              <a:shade val="50000"/>
+            </a:schemeClr>
+          </a:lnRef>
+          <a:fillRef idx="1">
+            <a:schemeClr val="accent1"/>
+          </a:fillRef>
+          <a:effectRef idx="0">
+            <a:schemeClr val="accent1"/>
+          </a:effectRef>
+          <a:fontRef idx="minor">
+            <a:schemeClr val="lt1"/>
+          </a:fontRef>
+        </p:style>
+        <p:txBody>
+          <a:bodyPr lIns="36000" tIns="18000" rIns="36000" bIns="18000" rtlCol="0" anchor="ctr">
+            <a:noAutofit/>
+          </a:bodyPr>
+          <a:lstStyle/>
+          <a:p>
+            <a:pPr algn="ctr"/>
+            <a:r>
+              <a:rPr lang="ko-KR" altLang="en-US" sz="900" b="1" dirty="0">
+                <a:solidFill>
+                  <a:schemeClr val="tx1"/>
+                </a:solidFill>
+              </a:rPr>
+              <a:t>Worker</a:t>
+            </a:r>
+          </a:p>
+        </p:txBody>
+      </p:sp>
+      <p:sp>
+        <p:nvSpPr>
+          <p:cNvPr id="112" name="Model Runner · Block Table"/>
+          <p:cNvSpPr/>
+          <p:nvPr/>
+        </p:nvSpPr>
+        <p:spPr>
+          <a:xfrm>
+            <a:off x="9850000" y="1660000"/>
+            <a:ext cx="1850000" cy="300000"/>
           </a:xfrm>
           <a:prstGeom prst="rect">
             <a:avLst/>
@@ -5663,24 +5752,32 @@
               <a:lumOff val="80000"/>
             </a:schemeClr>
           </a:solidFill>
-          <a:ln/>
+          <a:ln w="12700">
+            <a:solidFill>
+              <a:schemeClr val="tx1"/>
+            </a:solidFill>
+          </a:ln>
         </p:spPr>
         <p:style>
           <a:lnRef idx="2">
-            <a:schemeClr val="dk1"/>
+            <a:schemeClr val="accent1">
+              <a:shade val="50000"/>
+            </a:schemeClr>
           </a:lnRef>
           <a:fillRef idx="1">
-            <a:schemeClr val="lt1"/>
+            <a:schemeClr val="accent1"/>
           </a:fillRef>
           <a:effectRef idx="0">
-            <a:schemeClr val="dk1"/>
+            <a:schemeClr val="accent1"/>
           </a:effectRef>
           <a:fontRef idx="minor">
-            <a:schemeClr val="dk1"/>
+            <a:schemeClr val="lt1"/>
           </a:fontRef>
         </p:style>
         <p:txBody>
-          <a:bodyPr lIns="36000" rIns="36000" tIns="18000" bIns="18000" rtlCol="0" anchor="ctr"/>
+          <a:bodyPr lIns="36000" tIns="18000" rIns="36000" bIns="18000" rtlCol="0" anchor="ctr">
+            <a:noAutofit/>
+          </a:bodyPr>
           <a:lstStyle/>
           <a:p>
             <a:pPr algn="ctr"/>
@@ -5690,396 +5787,21 @@
                   <a:schemeClr val="tx1"/>
                 </a:solidFill>
               </a:rPr>
-              <a:t>Migration Scheduler</a:t>
-            </a:r>
-          </a:p>
-        </p:txBody>
-      </p:sp>
-      <p:sp>
-        <p:nvSpPr>
-          <p:cNvPr id="112" name="Resource · Behavior Analyzer"/>
+              <a:t>Model Runner · Block Table</a:t>
+            </a:r>
+          </a:p>
+        </p:txBody>
+      </p:sp>
+      <p:sp>
+        <p:nvSpPr>
+          <p:cNvPr id="113" name="DecisionPlane"/>
           <p:cNvSpPr/>
           <p:nvPr/>
         </p:nvSpPr>
         <p:spPr>
           <a:xfrm>
-            <a:off x="650000" y="3400000"/>
-            <a:ext cx="1450000" cy="360000"/>
-          </a:xfrm>
-          <a:prstGeom prst="rect">
-            <a:avLst/>
-          </a:prstGeom>
-          <a:solidFill>
-            <a:schemeClr val="accent4">
-              <a:lumMod val="20000"/>
-              <a:lumOff val="80000"/>
-            </a:schemeClr>
-          </a:solidFill>
-          <a:ln/>
-        </p:spPr>
-        <p:style>
-          <a:lnRef idx="2">
-            <a:schemeClr val="dk1"/>
-          </a:lnRef>
-          <a:fillRef idx="1">
-            <a:schemeClr val="lt1"/>
-          </a:fillRef>
-          <a:effectRef idx="0">
-            <a:schemeClr val="dk1"/>
-          </a:effectRef>
-          <a:fontRef idx="minor">
-            <a:schemeClr val="dk1"/>
-          </a:fontRef>
-        </p:style>
-        <p:txBody>
-          <a:bodyPr lIns="36000" rIns="36000" tIns="18000" bIns="18000" rtlCol="0" anchor="ctr"/>
-          <a:lstStyle/>
-          <a:p>
-            <a:pPr algn="ctr"/>
-            <a:r>
-              <a:rPr lang="ko-KR" altLang="en-US" sz="900" b="1" dirty="0">
-                <a:solidFill>
-                  <a:schemeClr val="tx1"/>
-                </a:solidFill>
-              </a:rPr>
-              <a:t>Resource · Behavior Analyzer</a:t>
-            </a:r>
-          </a:p>
-        </p:txBody>
-      </p:sp>
-      <p:sp>
-        <p:nvSpPr>
-          <p:cNvPr id="113" name="Eviction · Affinity Mapper"/>
-          <p:cNvSpPr/>
-          <p:nvPr/>
-        </p:nvSpPr>
-        <p:spPr>
-          <a:xfrm>
-            <a:off x="650000" y="3900000"/>
-            <a:ext cx="1450000" cy="360000"/>
-          </a:xfrm>
-          <a:prstGeom prst="rect">
-            <a:avLst/>
-          </a:prstGeom>
-          <a:solidFill>
-            <a:schemeClr val="accent4">
-              <a:lumMod val="20000"/>
-              <a:lumOff val="80000"/>
-            </a:schemeClr>
-          </a:solidFill>
-          <a:ln/>
-        </p:spPr>
-        <p:style>
-          <a:lnRef idx="2">
-            <a:schemeClr val="dk1"/>
-          </a:lnRef>
-          <a:fillRef idx="1">
-            <a:schemeClr val="lt1"/>
-          </a:fillRef>
-          <a:effectRef idx="0">
-            <a:schemeClr val="dk1"/>
-          </a:effectRef>
-          <a:fontRef idx="minor">
-            <a:schemeClr val="dk1"/>
-          </a:fontRef>
-        </p:style>
-        <p:txBody>
-          <a:bodyPr lIns="36000" rIns="36000" tIns="18000" bIns="18000" rtlCol="0" anchor="ctr"/>
-          <a:lstStyle/>
-          <a:p>
-            <a:pPr algn="ctr"/>
-            <a:r>
-              <a:rPr lang="ko-KR" altLang="en-US" sz="900" b="1" dirty="0">
-                <a:solidFill>
-                  <a:schemeClr val="tx1"/>
-                </a:solidFill>
-              </a:rPr>
-              <a:t>Eviction · Affinity Mapper</a:t>
-            </a:r>
-          </a:p>
-        </p:txBody>
-      </p:sp>
-      <p:sp>
-        <p:nvSpPr>
-          <p:cNvPr id="114" name="Destination Tier Selector"/>
-          <p:cNvSpPr/>
-          <p:nvPr/>
-        </p:nvSpPr>
-        <p:spPr>
-          <a:xfrm>
-            <a:off x="650000" y="4400000"/>
-            <a:ext cx="1450000" cy="360000"/>
-          </a:xfrm>
-          <a:prstGeom prst="rect">
-            <a:avLst/>
-          </a:prstGeom>
-          <a:solidFill>
-            <a:schemeClr val="accent4">
-              <a:lumMod val="20000"/>
-              <a:lumOff val="80000"/>
-            </a:schemeClr>
-          </a:solidFill>
-          <a:ln/>
-        </p:spPr>
-        <p:style>
-          <a:lnRef idx="2">
-            <a:schemeClr val="dk1"/>
-          </a:lnRef>
-          <a:fillRef idx="1">
-            <a:schemeClr val="lt1"/>
-          </a:fillRef>
-          <a:effectRef idx="0">
-            <a:schemeClr val="dk1"/>
-          </a:effectRef>
-          <a:fontRef idx="minor">
-            <a:schemeClr val="dk1"/>
-          </a:fontRef>
-        </p:style>
-        <p:txBody>
-          <a:bodyPr lIns="36000" rIns="36000" tIns="18000" bIns="18000" rtlCol="0" anchor="ctr"/>
-          <a:lstStyle/>
-          <a:p>
-            <a:pPr algn="ctr"/>
-            <a:r>
-              <a:rPr lang="ko-KR" altLang="en-US" sz="900" b="1" dirty="0">
-                <a:solidFill>
-                  <a:schemeClr val="tx1"/>
-                </a:solidFill>
-              </a:rPr>
-              <a:t>Destination Tier Selector</a:t>
-            </a:r>
-          </a:p>
-        </p:txBody>
-      </p:sp>
-      <p:sp>
-        <p:nvSpPr>
-          <p:cNvPr id="115" name="Access Cost Estimator"/>
-          <p:cNvSpPr/>
-          <p:nvPr/>
-        </p:nvSpPr>
-        <p:spPr>
-          <a:xfrm>
-            <a:off x="650000" y="4900000"/>
-            <a:ext cx="1450000" cy="360000"/>
-          </a:xfrm>
-          <a:prstGeom prst="rect">
-            <a:avLst/>
-          </a:prstGeom>
-          <a:solidFill>
-            <a:schemeClr val="accent4">
-              <a:lumMod val="20000"/>
-              <a:lumOff val="80000"/>
-            </a:schemeClr>
-          </a:solidFill>
-          <a:ln/>
-        </p:spPr>
-        <p:style>
-          <a:lnRef idx="2">
-            <a:schemeClr val="dk1"/>
-          </a:lnRef>
-          <a:fillRef idx="1">
-            <a:schemeClr val="lt1"/>
-          </a:fillRef>
-          <a:effectRef idx="0">
-            <a:schemeClr val="dk1"/>
-          </a:effectRef>
-          <a:fontRef idx="minor">
-            <a:schemeClr val="dk1"/>
-          </a:fontRef>
-        </p:style>
-        <p:txBody>
-          <a:bodyPr lIns="36000" rIns="36000" tIns="18000" bIns="18000" rtlCol="0" anchor="ctr"/>
-          <a:lstStyle/>
-          <a:p>
-            <a:pPr algn="ctr"/>
-            <a:r>
-              <a:rPr lang="ko-KR" altLang="en-US" sz="900" b="1" dirty="0">
-                <a:solidFill>
-                  <a:schemeClr val="tx1"/>
-                </a:solidFill>
-              </a:rPr>
-              <a:t>Access Cost Estimator</a:t>
-            </a:r>
-          </a:p>
-        </p:txBody>
-      </p:sp>
-      <p:sp>
-        <p:nvSpPr>
-          <p:cNvPr id="116" name="Resource Manager"/>
-          <p:cNvSpPr/>
-          <p:nvPr/>
-        </p:nvSpPr>
-        <p:spPr>
-          <a:xfrm>
-            <a:off x="2350000" y="2900000"/>
-            <a:ext cx="1450000" cy="360000"/>
-          </a:xfrm>
-          <a:prstGeom prst="rect">
-            <a:avLst/>
-          </a:prstGeom>
-          <a:solidFill>
-            <a:schemeClr val="accent4">
-              <a:lumMod val="20000"/>
-              <a:lumOff val="80000"/>
-            </a:schemeClr>
-          </a:solidFill>
-          <a:ln/>
-        </p:spPr>
-        <p:style>
-          <a:lnRef idx="2">
-            <a:schemeClr val="dk1"/>
-          </a:lnRef>
-          <a:fillRef idx="1">
-            <a:schemeClr val="lt1"/>
-          </a:fillRef>
-          <a:effectRef idx="0">
-            <a:schemeClr val="dk1"/>
-          </a:effectRef>
-          <a:fontRef idx="minor">
-            <a:schemeClr val="dk1"/>
-          </a:fontRef>
-        </p:style>
-        <p:txBody>
-          <a:bodyPr lIns="36000" rIns="36000" tIns="18000" bIns="18000" rtlCol="0" anchor="ctr"/>
-          <a:lstStyle/>
-          <a:p>
-            <a:pPr algn="ctr"/>
-            <a:r>
-              <a:rPr lang="ko-KR" altLang="en-US" sz="900" b="1" dirty="0">
-                <a:solidFill>
-                  <a:schemeClr val="tx1"/>
-                </a:solidFill>
-              </a:rPr>
-              <a:t>Resource Manager</a:t>
-            </a:r>
-          </a:p>
-          <a:p>
-            <a:pPr algn="ctr"/>
-            <a:r>
-              <a:rPr lang="ko-KR" altLang="en-US" sz="750" dirty="0">
-                <a:solidFill>
-                  <a:schemeClr val="tx1"/>
-                </a:solidFill>
-              </a:rPr>
-              <a:t>(Telemetry · Registry)</a:t>
-            </a:r>
-          </a:p>
-        </p:txBody>
-      </p:sp>
-      <p:sp>
-        <p:nvSpPr>
-          <p:cNvPr id="117" name="Migration Data Selector"/>
-          <p:cNvSpPr/>
-          <p:nvPr/>
-        </p:nvSpPr>
-        <p:spPr>
-          <a:xfrm>
-            <a:off x="2350000" y="4400000"/>
-            <a:ext cx="1450000" cy="360000"/>
-          </a:xfrm>
-          <a:prstGeom prst="rect">
-            <a:avLst/>
-          </a:prstGeom>
-          <a:solidFill>
-            <a:schemeClr val="accent4">
-              <a:lumMod val="20000"/>
-              <a:lumOff val="80000"/>
-            </a:schemeClr>
-          </a:solidFill>
-          <a:ln/>
-        </p:spPr>
-        <p:style>
-          <a:lnRef idx="2">
-            <a:schemeClr val="dk1"/>
-          </a:lnRef>
-          <a:fillRef idx="1">
-            <a:schemeClr val="lt1"/>
-          </a:fillRef>
-          <a:effectRef idx="0">
-            <a:schemeClr val="dk1"/>
-          </a:effectRef>
-          <a:fontRef idx="minor">
-            <a:schemeClr val="dk1"/>
-          </a:fontRef>
-        </p:style>
-        <p:txBody>
-          <a:bodyPr lIns="36000" rIns="36000" tIns="18000" bIns="18000" rtlCol="0" anchor="ctr"/>
-          <a:lstStyle/>
-          <a:p>
-            <a:pPr algn="ctr"/>
-            <a:r>
-              <a:rPr lang="ko-KR" altLang="en-US" sz="900" b="1" dirty="0">
-                <a:solidFill>
-                  <a:schemeClr val="tx1"/>
-                </a:solidFill>
-              </a:rPr>
-              <a:t>Migration Data Selector</a:t>
-            </a:r>
-          </a:p>
-        </p:txBody>
-      </p:sp>
-      <p:sp>
-        <p:nvSpPr>
-          <p:cNvPr id="118" name="Data Object Registry"/>
-          <p:cNvSpPr/>
-          <p:nvPr/>
-        </p:nvSpPr>
-        <p:spPr>
-          <a:xfrm>
-            <a:off x="2350000" y="4900000"/>
-            <a:ext cx="1450000" cy="360000"/>
-          </a:xfrm>
-          <a:prstGeom prst="rect">
-            <a:avLst/>
-          </a:prstGeom>
-          <a:solidFill>
-            <a:schemeClr val="accent4">
-              <a:lumMod val="20000"/>
-              <a:lumOff val="80000"/>
-            </a:schemeClr>
-          </a:solidFill>
-          <a:ln/>
-        </p:spPr>
-        <p:style>
-          <a:lnRef idx="2">
-            <a:schemeClr val="dk1"/>
-          </a:lnRef>
-          <a:fillRef idx="1">
-            <a:schemeClr val="lt1"/>
-          </a:fillRef>
-          <a:effectRef idx="0">
-            <a:schemeClr val="dk1"/>
-          </a:effectRef>
-          <a:fontRef idx="minor">
-            <a:schemeClr val="dk1"/>
-          </a:fontRef>
-        </p:style>
-        <p:txBody>
-          <a:bodyPr lIns="36000" rIns="36000" tIns="18000" bIns="18000" rtlCol="0" anchor="ctr"/>
-          <a:lstStyle/>
-          <a:p>
-            <a:pPr algn="ctr"/>
-            <a:r>
-              <a:rPr lang="ko-KR" altLang="en-US" sz="900" b="1" dirty="0">
-                <a:solidFill>
-                  <a:schemeClr val="tx1"/>
-                </a:solidFill>
-              </a:rPr>
-              <a:t>Data Object Registry</a:t>
-            </a:r>
-          </a:p>
-        </p:txBody>
-      </p:sp>
-      <p:sp>
-        <p:nvSpPr>
-          <p:cNvPr id="119" name="ControlPlane"/>
-          <p:cNvSpPr/>
-          <p:nvPr/>
-        </p:nvSpPr>
-        <p:spPr>
-          <a:xfrm>
-            <a:off x="4950000" y="2500000"/>
-            <a:ext cx="2900000" cy="2900000"/>
+            <a:off x="400000" y="2360000"/>
+            <a:ext cx="3550000" cy="2950000"/>
           </a:xfrm>
           <a:prstGeom prst="rect">
             <a:avLst/>
@@ -6113,7 +5835,9 @@
           </a:fontRef>
         </p:style>
         <p:txBody>
-          <a:bodyPr rtlCol="0" anchor="t"/>
+          <a:bodyPr lIns="36000" tIns="18000" rIns="36000" bIns="0" rtlCol="0" anchor="t">
+            <a:noAutofit/>
+          </a:bodyPr>
           <a:lstStyle/>
           <a:p>
             <a:pPr algn="ctr"/>
@@ -6123,20 +5847,20 @@
                   <a:schemeClr val="tx1"/>
                 </a:solidFill>
               </a:rPr>
-              <a:t>Control Plane · DP-5 (EngineCore 측)</a:t>
-            </a:r>
-          </a:p>
-        </p:txBody>
-      </p:sp>
-      <p:sp>
-        <p:nvSpPr>
-          <p:cNvPr id="120" name="ControlPlane tab"/>
+              <a:t>Decision Plane · DP-1</a:t>
+            </a:r>
+          </a:p>
+        </p:txBody>
+      </p:sp>
+      <p:sp>
+        <p:nvSpPr>
+          <p:cNvPr id="114" name="DecisionPlane tab"/>
           <p:cNvSpPr/>
           <p:nvPr/>
         </p:nvSpPr>
         <p:spPr>
           <a:xfrm>
-            <a:off x="4950000" y="2370000"/>
+            <a:off x="400000" y="2230000"/>
             <a:ext cx="264000" cy="131000"/>
           </a:xfrm>
           <a:prstGeom prst="rect">
@@ -6171,305 +5895,25 @@
           </a:fontRef>
         </p:style>
         <p:txBody>
-          <a:bodyPr rtlCol="0" anchor="ctr"/>
-          <a:lstStyle/>
-          <a:p>
-            <a:endParaRPr lang="ko-KR" altLang="en-US"/>
-          </a:p>
-        </p:txBody>
-      </p:sp>
-      <p:sp>
-        <p:nvSpPr>
-          <p:cNvPr id="121" name="Migration Planner / Queue"/>
+          <a:bodyPr lIns="36000" tIns="18000" rIns="36000" bIns="18000" rtlCol="0" anchor="ctr">
+            <a:noAutofit/>
+          </a:bodyPr>
+          <a:lstStyle/>
+          <a:p>
+            <a:endParaRPr lang="ko-KR"/>
+          </a:p>
+        </p:txBody>
+      </p:sp>
+      <p:sp>
+        <p:nvSpPr>
+          <p:cNvPr id="115" name="ControlPlane"/>
           <p:cNvSpPr/>
           <p:nvPr/>
         </p:nvSpPr>
         <p:spPr>
           <a:xfrm>
-            <a:off x="6500000" y="2900000"/>
-            <a:ext cx="1250000" cy="360000"/>
-          </a:xfrm>
-          <a:prstGeom prst="rect">
-            <a:avLst/>
-          </a:prstGeom>
-          <a:solidFill>
-            <a:schemeClr val="accent4">
-              <a:lumMod val="20000"/>
-              <a:lumOff val="80000"/>
-            </a:schemeClr>
-          </a:solidFill>
-          <a:ln/>
-        </p:spPr>
-        <p:style>
-          <a:lnRef idx="2">
-            <a:schemeClr val="dk1"/>
-          </a:lnRef>
-          <a:fillRef idx="1">
-            <a:schemeClr val="lt1"/>
-          </a:fillRef>
-          <a:effectRef idx="0">
-            <a:schemeClr val="dk1"/>
-          </a:effectRef>
-          <a:fontRef idx="minor">
-            <a:schemeClr val="dk1"/>
-          </a:fontRef>
-        </p:style>
-        <p:txBody>
-          <a:bodyPr lIns="36000" rIns="36000" tIns="18000" bIns="18000" rtlCol="0" anchor="ctr"/>
-          <a:lstStyle/>
-          <a:p>
-            <a:pPr algn="ctr"/>
-            <a:r>
-              <a:rPr lang="ko-KR" altLang="en-US" sz="900" b="1" dirty="0">
-                <a:solidFill>
-                  <a:schemeClr val="tx1"/>
-                </a:solidFill>
-              </a:rPr>
-              <a:t>Migration Planner / Queue</a:t>
-            </a:r>
-          </a:p>
-        </p:txBody>
-      </p:sp>
-      <p:sp>
-        <p:nvSpPr>
-          <p:cNvPr id="122" name="Access Guard"/>
-          <p:cNvSpPr/>
-          <p:nvPr/>
-        </p:nvSpPr>
-        <p:spPr>
-          <a:xfrm>
-            <a:off x="6500000" y="3900000"/>
-            <a:ext cx="1250000" cy="360000"/>
-          </a:xfrm>
-          <a:prstGeom prst="rect">
-            <a:avLst/>
-          </a:prstGeom>
-          <a:solidFill>
-            <a:schemeClr val="accent4">
-              <a:lumMod val="20000"/>
-              <a:lumOff val="80000"/>
-            </a:schemeClr>
-          </a:solidFill>
-          <a:ln/>
-        </p:spPr>
-        <p:style>
-          <a:lnRef idx="2">
-            <a:schemeClr val="dk1"/>
-          </a:lnRef>
-          <a:fillRef idx="1">
-            <a:schemeClr val="lt1"/>
-          </a:fillRef>
-          <a:effectRef idx="0">
-            <a:schemeClr val="dk1"/>
-          </a:effectRef>
-          <a:fontRef idx="minor">
-            <a:schemeClr val="dk1"/>
-          </a:fontRef>
-        </p:style>
-        <p:txBody>
-          <a:bodyPr lIns="36000" rIns="36000" tIns="18000" bIns="18000" rtlCol="0" anchor="ctr"/>
-          <a:lstStyle/>
-          <a:p>
-            <a:pPr algn="ctr"/>
-            <a:r>
-              <a:rPr lang="ko-KR" altLang="en-US" sz="900" b="1" dirty="0">
-                <a:solidFill>
-                  <a:schemeClr val="tx1"/>
-                </a:solidFill>
-              </a:rPr>
-              <a:t>Access Guard</a:t>
-            </a:r>
-          </a:p>
-          <a:p>
-            <a:pPr algn="ctr"/>
-            <a:r>
-              <a:rPr lang="ko-KR" altLang="en-US" sz="750" dirty="0">
-                <a:solidFill>
-                  <a:schemeClr val="tx1"/>
-                </a:solidFill>
-              </a:rPr>
-              <a:t>(pin · epoch)</a:t>
-            </a:r>
-          </a:p>
-        </p:txBody>
-      </p:sp>
-      <p:sp>
-        <p:nvSpPr>
-          <p:cNvPr id="123" name="Data Location Store"/>
-          <p:cNvSpPr/>
-          <p:nvPr/>
-        </p:nvSpPr>
-        <p:spPr>
-          <a:xfrm>
-            <a:off x="6500000" y="4400000"/>
-            <a:ext cx="1250000" cy="360000"/>
-          </a:xfrm>
-          <a:prstGeom prst="rect">
-            <a:avLst/>
-          </a:prstGeom>
-          <a:solidFill>
-            <a:schemeClr val="accent4">
-              <a:lumMod val="20000"/>
-              <a:lumOff val="80000"/>
-            </a:schemeClr>
-          </a:solidFill>
-          <a:ln/>
-        </p:spPr>
-        <p:style>
-          <a:lnRef idx="2">
-            <a:schemeClr val="dk1"/>
-          </a:lnRef>
-          <a:fillRef idx="1">
-            <a:schemeClr val="lt1"/>
-          </a:fillRef>
-          <a:effectRef idx="0">
-            <a:schemeClr val="dk1"/>
-          </a:effectRef>
-          <a:fontRef idx="minor">
-            <a:schemeClr val="dk1"/>
-          </a:fontRef>
-        </p:style>
-        <p:txBody>
-          <a:bodyPr lIns="36000" rIns="36000" tIns="18000" bIns="18000" rtlCol="0" anchor="ctr"/>
-          <a:lstStyle/>
-          <a:p>
-            <a:pPr algn="ctr"/>
-            <a:r>
-              <a:rPr lang="ko-KR" altLang="en-US" sz="900" b="1" dirty="0">
-                <a:solidFill>
-                  <a:schemeClr val="tx1"/>
-                </a:solidFill>
-              </a:rPr>
-              <a:t>Data Location Store</a:t>
-            </a:r>
-          </a:p>
-          <a:p>
-            <a:pPr algn="ctr"/>
-            <a:r>
-              <a:rPr lang="ko-KR" altLang="en-US" sz="750" dirty="0">
-                <a:solidFill>
-                  <a:schemeClr val="tx1"/>
-                </a:solidFill>
-              </a:rPr>
-              <a:t>(authoritative)</a:t>
-            </a:r>
-          </a:p>
-        </p:txBody>
-      </p:sp>
-      <p:sp>
-        <p:nvSpPr>
-          <p:cNvPr id="124" name="Migration Coordinator"/>
-          <p:cNvSpPr/>
-          <p:nvPr/>
-        </p:nvSpPr>
-        <p:spPr>
-          <a:xfrm>
-            <a:off x="5030000" y="4400000"/>
-            <a:ext cx="1250000" cy="360000"/>
-          </a:xfrm>
-          <a:prstGeom prst="rect">
-            <a:avLst/>
-          </a:prstGeom>
-          <a:solidFill>
-            <a:schemeClr val="accent4">
-              <a:lumMod val="20000"/>
-              <a:lumOff val="80000"/>
-            </a:schemeClr>
-          </a:solidFill>
-          <a:ln/>
-        </p:spPr>
-        <p:style>
-          <a:lnRef idx="2">
-            <a:schemeClr val="dk1"/>
-          </a:lnRef>
-          <a:fillRef idx="1">
-            <a:schemeClr val="lt1"/>
-          </a:fillRef>
-          <a:effectRef idx="0">
-            <a:schemeClr val="dk1"/>
-          </a:effectRef>
-          <a:fontRef idx="minor">
-            <a:schemeClr val="dk1"/>
-          </a:fontRef>
-        </p:style>
-        <p:txBody>
-          <a:bodyPr lIns="36000" rIns="36000" tIns="18000" bIns="18000" rtlCol="0" anchor="ctr"/>
-          <a:lstStyle/>
-          <a:p>
-            <a:pPr algn="ctr"/>
-            <a:r>
-              <a:rPr lang="ko-KR" altLang="en-US" sz="900" b="1" dirty="0">
-                <a:solidFill>
-                  <a:schemeClr val="tx1"/>
-                </a:solidFill>
-              </a:rPr>
-              <a:t>Migration Coordinator</a:t>
-            </a:r>
-          </a:p>
-        </p:txBody>
-      </p:sp>
-      <p:sp>
-        <p:nvSpPr>
-          <p:cNvPr id="125" name="Completion Reconciler"/>
-          <p:cNvSpPr/>
-          <p:nvPr/>
-        </p:nvSpPr>
-        <p:spPr>
-          <a:xfrm>
-            <a:off x="5030000" y="4900000"/>
-            <a:ext cx="1250000" cy="360000"/>
-          </a:xfrm>
-          <a:prstGeom prst="rect">
-            <a:avLst/>
-          </a:prstGeom>
-          <a:solidFill>
-            <a:schemeClr val="accent4">
-              <a:lumMod val="20000"/>
-              <a:lumOff val="80000"/>
-            </a:schemeClr>
-          </a:solidFill>
-          <a:ln/>
-        </p:spPr>
-        <p:style>
-          <a:lnRef idx="2">
-            <a:schemeClr val="dk1"/>
-          </a:lnRef>
-          <a:fillRef idx="1">
-            <a:schemeClr val="lt1"/>
-          </a:fillRef>
-          <a:effectRef idx="0">
-            <a:schemeClr val="dk1"/>
-          </a:effectRef>
-          <a:fontRef idx="minor">
-            <a:schemeClr val="dk1"/>
-          </a:fontRef>
-        </p:style>
-        <p:txBody>
-          <a:bodyPr lIns="36000" rIns="36000" tIns="18000" bIns="18000" rtlCol="0" anchor="ctr"/>
-          <a:lstStyle/>
-          <a:p>
-            <a:pPr algn="ctr"/>
-            <a:r>
-              <a:rPr lang="ko-KR" altLang="en-US" sz="900" b="1" dirty="0">
-                <a:solidFill>
-                  <a:schemeClr val="tx1"/>
-                </a:solidFill>
-              </a:rPr>
-              <a:t>Completion Reconciler</a:t>
-            </a:r>
-          </a:p>
-        </p:txBody>
-      </p:sp>
-      <p:sp>
-        <p:nvSpPr>
-          <p:cNvPr id="126" name="Compute"/>
-          <p:cNvSpPr/>
-          <p:nvPr/>
-        </p:nvSpPr>
-        <p:spPr>
-          <a:xfrm>
-            <a:off x="8800000" y="1450000"/>
-            <a:ext cx="2850000" cy="750000"/>
+            <a:off x="4850000" y="2360000"/>
+            <a:ext cx="3200000" cy="2950000"/>
           </a:xfrm>
           <a:prstGeom prst="rect">
             <a:avLst/>
@@ -6503,7 +5947,9 @@
           </a:fontRef>
         </p:style>
         <p:txBody>
-          <a:bodyPr rtlCol="0" anchor="t"/>
+          <a:bodyPr lIns="36000" tIns="18000" rIns="36000" bIns="0" rtlCol="0" anchor="t">
+            <a:noAutofit/>
+          </a:bodyPr>
           <a:lstStyle/>
           <a:p>
             <a:pPr algn="ctr"/>
@@ -6513,20 +5959,20 @@
                   <a:schemeClr val="tx1"/>
                 </a:solidFill>
               </a:rPr>
-              <a:t>Compute Management</a:t>
-            </a:r>
-          </a:p>
-        </p:txBody>
-      </p:sp>
-      <p:sp>
-        <p:nvSpPr>
-          <p:cNvPr id="127" name="Compute tab"/>
+              <a:t>Control Plane · DP-5</a:t>
+            </a:r>
+          </a:p>
+        </p:txBody>
+      </p:sp>
+      <p:sp>
+        <p:nvSpPr>
+          <p:cNvPr id="116" name="ControlPlane tab"/>
           <p:cNvSpPr/>
           <p:nvPr/>
         </p:nvSpPr>
         <p:spPr>
           <a:xfrm>
-            <a:off x="8800000" y="1320000"/>
+            <a:off x="4850000" y="2230000"/>
             <a:ext cx="264000" cy="131000"/>
           </a:xfrm>
           <a:prstGeom prst="rect">
@@ -6561,127 +6007,25 @@
           </a:fontRef>
         </p:style>
         <p:txBody>
-          <a:bodyPr rtlCol="0" anchor="ctr"/>
-          <a:lstStyle/>
-          <a:p>
-            <a:endParaRPr lang="ko-KR" altLang="en-US"/>
-          </a:p>
-        </p:txBody>
-      </p:sp>
-      <p:sp>
-        <p:nvSpPr>
-          <p:cNvPr id="128" name="Worker"/>
+          <a:bodyPr lIns="36000" tIns="18000" rIns="36000" bIns="18000" rtlCol="0" anchor="ctr">
+            <a:noAutofit/>
+          </a:bodyPr>
+          <a:lstStyle/>
+          <a:p>
+            <a:endParaRPr lang="ko-KR"/>
+          </a:p>
+        </p:txBody>
+      </p:sp>
+      <p:sp>
+        <p:nvSpPr>
+          <p:cNvPr id="117" name="DataTransferPlane"/>
           <p:cNvSpPr/>
           <p:nvPr/>
         </p:nvSpPr>
         <p:spPr>
           <a:xfrm>
-            <a:off x="8880000" y="1800000"/>
-            <a:ext cx="1100000" cy="340000"/>
-          </a:xfrm>
-          <a:prstGeom prst="rect">
-            <a:avLst/>
-          </a:prstGeom>
-          <a:solidFill>
-            <a:schemeClr val="accent4">
-              <a:lumMod val="20000"/>
-              <a:lumOff val="80000"/>
-            </a:schemeClr>
-          </a:solidFill>
-          <a:ln/>
-        </p:spPr>
-        <p:style>
-          <a:lnRef idx="2">
-            <a:schemeClr val="dk1"/>
-          </a:lnRef>
-          <a:fillRef idx="1">
-            <a:schemeClr val="lt1"/>
-          </a:fillRef>
-          <a:effectRef idx="0">
-            <a:schemeClr val="dk1"/>
-          </a:effectRef>
-          <a:fontRef idx="minor">
-            <a:schemeClr val="dk1"/>
-          </a:fontRef>
-        </p:style>
-        <p:txBody>
-          <a:bodyPr lIns="36000" rIns="36000" tIns="18000" bIns="18000" rtlCol="0" anchor="ctr"/>
-          <a:lstStyle/>
-          <a:p>
-            <a:pPr algn="ctr"/>
-            <a:r>
-              <a:rPr lang="ko-KR" altLang="en-US" sz="900" b="1" dirty="0">
-                <a:solidFill>
-                  <a:schemeClr val="tx1"/>
-                </a:solidFill>
-              </a:rPr>
-              <a:t>Worker</a:t>
-            </a:r>
-          </a:p>
-        </p:txBody>
-      </p:sp>
-      <p:sp>
-        <p:nvSpPr>
-          <p:cNvPr id="129" name="Model Runner · Block Table"/>
-          <p:cNvSpPr/>
-          <p:nvPr/>
-        </p:nvSpPr>
-        <p:spPr>
-          <a:xfrm>
-            <a:off x="10080000" y="1800000"/>
-            <a:ext cx="1490000" cy="340000"/>
-          </a:xfrm>
-          <a:prstGeom prst="rect">
-            <a:avLst/>
-          </a:prstGeom>
-          <a:solidFill>
-            <a:schemeClr val="accent4">
-              <a:lumMod val="20000"/>
-              <a:lumOff val="80000"/>
-            </a:schemeClr>
-          </a:solidFill>
-          <a:ln/>
-        </p:spPr>
-        <p:style>
-          <a:lnRef idx="2">
-            <a:schemeClr val="dk1"/>
-          </a:lnRef>
-          <a:fillRef idx="1">
-            <a:schemeClr val="lt1"/>
-          </a:fillRef>
-          <a:effectRef idx="0">
-            <a:schemeClr val="dk1"/>
-          </a:effectRef>
-          <a:fontRef idx="minor">
-            <a:schemeClr val="dk1"/>
-          </a:fontRef>
-        </p:style>
-        <p:txBody>
-          <a:bodyPr lIns="36000" rIns="36000" tIns="18000" bIns="18000" rtlCol="0" anchor="ctr"/>
-          <a:lstStyle/>
-          <a:p>
-            <a:pPr algn="ctr"/>
-            <a:r>
-              <a:rPr lang="ko-KR" altLang="en-US" sz="900" b="1" dirty="0">
-                <a:solidFill>
-                  <a:schemeClr val="tx1"/>
-                </a:solidFill>
-              </a:rPr>
-              <a:t>Model Runner · Block Table</a:t>
-            </a:r>
-          </a:p>
-        </p:txBody>
-      </p:sp>
-      <p:sp>
-        <p:nvSpPr>
-          <p:cNvPr id="130" name="DataPlane"/>
-          <p:cNvSpPr/>
-          <p:nvPr/>
-        </p:nvSpPr>
-        <p:spPr>
-          <a:xfrm>
-            <a:off x="8800000" y="2500000"/>
-            <a:ext cx="2850000" cy="2900000"/>
+            <a:off x="8750000" y="2360000"/>
+            <a:ext cx="3050000" cy="2950000"/>
           </a:xfrm>
           <a:prstGeom prst="rect">
             <a:avLst/>
@@ -6715,7 +6059,9 @@
           </a:fontRef>
         </p:style>
         <p:txBody>
-          <a:bodyPr rtlCol="0" anchor="t"/>
+          <a:bodyPr lIns="36000" tIns="18000" rIns="36000" bIns="0" rtlCol="0" anchor="t">
+            <a:noAutofit/>
+          </a:bodyPr>
           <a:lstStyle/>
           <a:p>
             <a:pPr algn="ctr"/>
@@ -6725,20 +6071,20 @@
                   <a:schemeClr val="tx1"/>
                 </a:solidFill>
               </a:rPr>
-              <a:t>Data Plane · DP-5 (Worker 측)</a:t>
-            </a:r>
-          </a:p>
-        </p:txBody>
-      </p:sp>
-      <p:sp>
-        <p:nvSpPr>
-          <p:cNvPr id="131" name="DataPlane tab"/>
+              <a:t>Data Transfer Plane · DP-5</a:t>
+            </a:r>
+          </a:p>
+        </p:txBody>
+      </p:sp>
+      <p:sp>
+        <p:nvSpPr>
+          <p:cNvPr id="118" name="DataTransferPlane tab"/>
           <p:cNvSpPr/>
           <p:nvPr/>
         </p:nvSpPr>
         <p:spPr>
           <a:xfrm>
-            <a:off x="8800000" y="2370000"/>
+            <a:off x="8750000" y="2230000"/>
             <a:ext cx="264000" cy="131000"/>
           </a:xfrm>
           <a:prstGeom prst="rect">
@@ -6773,23 +6119,25 @@
           </a:fontRef>
         </p:style>
         <p:txBody>
-          <a:bodyPr rtlCol="0" anchor="ctr"/>
-          <a:lstStyle/>
-          <a:p>
-            <a:endParaRPr lang="ko-KR" altLang="en-US"/>
-          </a:p>
-        </p:txBody>
-      </p:sp>
-      <p:sp>
-        <p:nvSpPr>
-          <p:cNvPr id="132" name="Migration Executor"/>
+          <a:bodyPr lIns="36000" tIns="18000" rIns="36000" bIns="18000" rtlCol="0" anchor="ctr">
+            <a:noAutofit/>
+          </a:bodyPr>
+          <a:lstStyle/>
+          <a:p>
+            <a:endParaRPr lang="ko-KR"/>
+          </a:p>
+        </p:txBody>
+      </p:sp>
+      <p:sp>
+        <p:nvSpPr>
+          <p:cNvPr id="119" name="Migration Scheduler"/>
           <p:cNvSpPr/>
           <p:nvPr/>
         </p:nvSpPr>
         <p:spPr>
           <a:xfrm>
-            <a:off x="8880000" y="2900000"/>
-            <a:ext cx="2690000" cy="360000"/>
+            <a:off x="500000" y="2780000"/>
+            <a:ext cx="1650000" cy="360000"/>
           </a:xfrm>
           <a:prstGeom prst="rect">
             <a:avLst/>
@@ -6800,24 +6148,845 @@
               <a:lumOff val="80000"/>
             </a:schemeClr>
           </a:solidFill>
-          <a:ln/>
+          <a:ln w="12700">
+            <a:solidFill>
+              <a:schemeClr val="tx1"/>
+            </a:solidFill>
+          </a:ln>
         </p:spPr>
         <p:style>
           <a:lnRef idx="2">
-            <a:schemeClr val="dk1"/>
+            <a:schemeClr val="accent1">
+              <a:shade val="50000"/>
+            </a:schemeClr>
           </a:lnRef>
           <a:fillRef idx="1">
-            <a:schemeClr val="lt1"/>
+            <a:schemeClr val="accent1"/>
           </a:fillRef>
           <a:effectRef idx="0">
-            <a:schemeClr val="dk1"/>
+            <a:schemeClr val="accent1"/>
           </a:effectRef>
           <a:fontRef idx="minor">
-            <a:schemeClr val="dk1"/>
+            <a:schemeClr val="lt1"/>
           </a:fontRef>
         </p:style>
         <p:txBody>
-          <a:bodyPr lIns="36000" rIns="36000" tIns="18000" bIns="18000" rtlCol="0" anchor="ctr"/>
+          <a:bodyPr lIns="36000" tIns="18000" rIns="36000" bIns="18000" rtlCol="0" anchor="ctr">
+            <a:noAutofit/>
+          </a:bodyPr>
+          <a:lstStyle/>
+          <a:p>
+            <a:pPr algn="ctr"/>
+            <a:r>
+              <a:rPr lang="ko-KR" altLang="en-US" sz="900" b="1" dirty="0">
+                <a:solidFill>
+                  <a:schemeClr val="tx1"/>
+                </a:solidFill>
+              </a:rPr>
+              <a:t>Migration Scheduler</a:t>
+            </a:r>
+          </a:p>
+        </p:txBody>
+      </p:sp>
+      <p:sp>
+        <p:nvSpPr>
+          <p:cNvPr id="120" name="Resource · Behavior Analyzer"/>
+          <p:cNvSpPr/>
+          <p:nvPr/>
+        </p:nvSpPr>
+        <p:spPr>
+          <a:xfrm>
+            <a:off x="500000" y="3280000"/>
+            <a:ext cx="1650000" cy="360000"/>
+          </a:xfrm>
+          <a:prstGeom prst="rect">
+            <a:avLst/>
+          </a:prstGeom>
+          <a:solidFill>
+            <a:schemeClr val="accent4">
+              <a:lumMod val="20000"/>
+              <a:lumOff val="80000"/>
+            </a:schemeClr>
+          </a:solidFill>
+          <a:ln w="12700">
+            <a:solidFill>
+              <a:schemeClr val="tx1"/>
+            </a:solidFill>
+          </a:ln>
+        </p:spPr>
+        <p:style>
+          <a:lnRef idx="2">
+            <a:schemeClr val="accent1">
+              <a:shade val="50000"/>
+            </a:schemeClr>
+          </a:lnRef>
+          <a:fillRef idx="1">
+            <a:schemeClr val="accent1"/>
+          </a:fillRef>
+          <a:effectRef idx="0">
+            <a:schemeClr val="accent1"/>
+          </a:effectRef>
+          <a:fontRef idx="minor">
+            <a:schemeClr val="lt1"/>
+          </a:fontRef>
+        </p:style>
+        <p:txBody>
+          <a:bodyPr lIns="36000" tIns="18000" rIns="36000" bIns="18000" rtlCol="0" anchor="ctr">
+            <a:noAutofit/>
+          </a:bodyPr>
+          <a:lstStyle/>
+          <a:p>
+            <a:pPr algn="ctr"/>
+            <a:r>
+              <a:rPr lang="ko-KR" altLang="en-US" sz="900" b="1" dirty="0">
+                <a:solidFill>
+                  <a:schemeClr val="tx1"/>
+                </a:solidFill>
+              </a:rPr>
+              <a:t>Resource · Behavior Analyzer</a:t>
+            </a:r>
+          </a:p>
+        </p:txBody>
+      </p:sp>
+      <p:sp>
+        <p:nvSpPr>
+          <p:cNvPr id="121" name="Eviction · Affinity Mapper"/>
+          <p:cNvSpPr/>
+          <p:nvPr/>
+        </p:nvSpPr>
+        <p:spPr>
+          <a:xfrm>
+            <a:off x="500000" y="3780000"/>
+            <a:ext cx="1650000" cy="360000"/>
+          </a:xfrm>
+          <a:prstGeom prst="rect">
+            <a:avLst/>
+          </a:prstGeom>
+          <a:solidFill>
+            <a:schemeClr val="accent4">
+              <a:lumMod val="20000"/>
+              <a:lumOff val="80000"/>
+            </a:schemeClr>
+          </a:solidFill>
+          <a:ln w="12700">
+            <a:solidFill>
+              <a:schemeClr val="tx1"/>
+            </a:solidFill>
+          </a:ln>
+        </p:spPr>
+        <p:style>
+          <a:lnRef idx="2">
+            <a:schemeClr val="accent1">
+              <a:shade val="50000"/>
+            </a:schemeClr>
+          </a:lnRef>
+          <a:fillRef idx="1">
+            <a:schemeClr val="accent1"/>
+          </a:fillRef>
+          <a:effectRef idx="0">
+            <a:schemeClr val="accent1"/>
+          </a:effectRef>
+          <a:fontRef idx="minor">
+            <a:schemeClr val="lt1"/>
+          </a:fontRef>
+        </p:style>
+        <p:txBody>
+          <a:bodyPr lIns="36000" tIns="18000" rIns="36000" bIns="18000" rtlCol="0" anchor="ctr">
+            <a:noAutofit/>
+          </a:bodyPr>
+          <a:lstStyle/>
+          <a:p>
+            <a:pPr algn="ctr"/>
+            <a:r>
+              <a:rPr lang="ko-KR" altLang="en-US" sz="900" b="1" dirty="0">
+                <a:solidFill>
+                  <a:schemeClr val="tx1"/>
+                </a:solidFill>
+              </a:rPr>
+              <a:t>Eviction · Affinity Mapper</a:t>
+            </a:r>
+          </a:p>
+        </p:txBody>
+      </p:sp>
+      <p:sp>
+        <p:nvSpPr>
+          <p:cNvPr id="122" name="Destination Tier Selector"/>
+          <p:cNvSpPr/>
+          <p:nvPr/>
+        </p:nvSpPr>
+        <p:spPr>
+          <a:xfrm>
+            <a:off x="500000" y="4280000"/>
+            <a:ext cx="1650000" cy="360000"/>
+          </a:xfrm>
+          <a:prstGeom prst="rect">
+            <a:avLst/>
+          </a:prstGeom>
+          <a:solidFill>
+            <a:schemeClr val="accent4">
+              <a:lumMod val="20000"/>
+              <a:lumOff val="80000"/>
+            </a:schemeClr>
+          </a:solidFill>
+          <a:ln w="12700">
+            <a:solidFill>
+              <a:schemeClr val="tx1"/>
+            </a:solidFill>
+          </a:ln>
+        </p:spPr>
+        <p:style>
+          <a:lnRef idx="2">
+            <a:schemeClr val="accent1">
+              <a:shade val="50000"/>
+            </a:schemeClr>
+          </a:lnRef>
+          <a:fillRef idx="1">
+            <a:schemeClr val="accent1"/>
+          </a:fillRef>
+          <a:effectRef idx="0">
+            <a:schemeClr val="accent1"/>
+          </a:effectRef>
+          <a:fontRef idx="minor">
+            <a:schemeClr val="lt1"/>
+          </a:fontRef>
+        </p:style>
+        <p:txBody>
+          <a:bodyPr lIns="36000" tIns="18000" rIns="36000" bIns="18000" rtlCol="0" anchor="ctr">
+            <a:noAutofit/>
+          </a:bodyPr>
+          <a:lstStyle/>
+          <a:p>
+            <a:pPr algn="ctr"/>
+            <a:r>
+              <a:rPr lang="ko-KR" altLang="en-US" sz="900" b="1" dirty="0">
+                <a:solidFill>
+                  <a:schemeClr val="tx1"/>
+                </a:solidFill>
+              </a:rPr>
+              <a:t>Destination Tier Selector</a:t>
+            </a:r>
+          </a:p>
+        </p:txBody>
+      </p:sp>
+      <p:sp>
+        <p:nvSpPr>
+          <p:cNvPr id="123" name="Access Cost Estimator"/>
+          <p:cNvSpPr/>
+          <p:nvPr/>
+        </p:nvSpPr>
+        <p:spPr>
+          <a:xfrm>
+            <a:off x="500000" y="4780000"/>
+            <a:ext cx="1650000" cy="360000"/>
+          </a:xfrm>
+          <a:prstGeom prst="rect">
+            <a:avLst/>
+          </a:prstGeom>
+          <a:solidFill>
+            <a:schemeClr val="accent4">
+              <a:lumMod val="20000"/>
+              <a:lumOff val="80000"/>
+            </a:schemeClr>
+          </a:solidFill>
+          <a:ln w="12700">
+            <a:solidFill>
+              <a:schemeClr val="tx1"/>
+            </a:solidFill>
+          </a:ln>
+        </p:spPr>
+        <p:style>
+          <a:lnRef idx="2">
+            <a:schemeClr val="accent1">
+              <a:shade val="50000"/>
+            </a:schemeClr>
+          </a:lnRef>
+          <a:fillRef idx="1">
+            <a:schemeClr val="accent1"/>
+          </a:fillRef>
+          <a:effectRef idx="0">
+            <a:schemeClr val="accent1"/>
+          </a:effectRef>
+          <a:fontRef idx="minor">
+            <a:schemeClr val="lt1"/>
+          </a:fontRef>
+        </p:style>
+        <p:txBody>
+          <a:bodyPr lIns="36000" tIns="18000" rIns="36000" bIns="18000" rtlCol="0" anchor="ctr">
+            <a:noAutofit/>
+          </a:bodyPr>
+          <a:lstStyle/>
+          <a:p>
+            <a:pPr algn="ctr"/>
+            <a:r>
+              <a:rPr lang="ko-KR" altLang="en-US" sz="900" b="1" dirty="0">
+                <a:solidFill>
+                  <a:schemeClr val="tx1"/>
+                </a:solidFill>
+              </a:rPr>
+              <a:t>Access Cost Estimator</a:t>
+            </a:r>
+          </a:p>
+        </p:txBody>
+      </p:sp>
+      <p:sp>
+        <p:nvSpPr>
+          <p:cNvPr id="124" name="Resource Manager"/>
+          <p:cNvSpPr/>
+          <p:nvPr/>
+        </p:nvSpPr>
+        <p:spPr>
+          <a:xfrm>
+            <a:off x="2200000" y="2780000"/>
+            <a:ext cx="1650000" cy="360000"/>
+          </a:xfrm>
+          <a:prstGeom prst="rect">
+            <a:avLst/>
+          </a:prstGeom>
+          <a:solidFill>
+            <a:schemeClr val="accent4">
+              <a:lumMod val="20000"/>
+              <a:lumOff val="80000"/>
+            </a:schemeClr>
+          </a:solidFill>
+          <a:ln w="12700">
+            <a:solidFill>
+              <a:schemeClr val="tx1"/>
+            </a:solidFill>
+          </a:ln>
+        </p:spPr>
+        <p:style>
+          <a:lnRef idx="2">
+            <a:schemeClr val="accent1">
+              <a:shade val="50000"/>
+            </a:schemeClr>
+          </a:lnRef>
+          <a:fillRef idx="1">
+            <a:schemeClr val="accent1"/>
+          </a:fillRef>
+          <a:effectRef idx="0">
+            <a:schemeClr val="accent1"/>
+          </a:effectRef>
+          <a:fontRef idx="minor">
+            <a:schemeClr val="lt1"/>
+          </a:fontRef>
+        </p:style>
+        <p:txBody>
+          <a:bodyPr lIns="36000" tIns="18000" rIns="36000" bIns="18000" rtlCol="0" anchor="ctr">
+            <a:noAutofit/>
+          </a:bodyPr>
+          <a:lstStyle/>
+          <a:p>
+            <a:pPr algn="ctr"/>
+            <a:r>
+              <a:rPr lang="ko-KR" altLang="en-US" sz="900" b="1" dirty="0">
+                <a:solidFill>
+                  <a:schemeClr val="tx1"/>
+                </a:solidFill>
+              </a:rPr>
+              <a:t>Resource Manager</a:t>
+            </a:r>
+          </a:p>
+          <a:p>
+            <a:pPr algn="ctr"/>
+            <a:r>
+              <a:rPr lang="ko-KR" altLang="en-US" sz="750" dirty="0">
+                <a:solidFill>
+                  <a:schemeClr val="tx1"/>
+                </a:solidFill>
+              </a:rPr>
+              <a:t>(Telemetry · Registry)</a:t>
+            </a:r>
+          </a:p>
+        </p:txBody>
+      </p:sp>
+      <p:sp>
+        <p:nvSpPr>
+          <p:cNvPr id="125" name="Migration Data Selector"/>
+          <p:cNvSpPr/>
+          <p:nvPr/>
+        </p:nvSpPr>
+        <p:spPr>
+          <a:xfrm>
+            <a:off x="2200000" y="4280000"/>
+            <a:ext cx="1650000" cy="360000"/>
+          </a:xfrm>
+          <a:prstGeom prst="rect">
+            <a:avLst/>
+          </a:prstGeom>
+          <a:solidFill>
+            <a:schemeClr val="accent4">
+              <a:lumMod val="20000"/>
+              <a:lumOff val="80000"/>
+            </a:schemeClr>
+          </a:solidFill>
+          <a:ln w="12700">
+            <a:solidFill>
+              <a:schemeClr val="tx1"/>
+            </a:solidFill>
+          </a:ln>
+        </p:spPr>
+        <p:style>
+          <a:lnRef idx="2">
+            <a:schemeClr val="accent1">
+              <a:shade val="50000"/>
+            </a:schemeClr>
+          </a:lnRef>
+          <a:fillRef idx="1">
+            <a:schemeClr val="accent1"/>
+          </a:fillRef>
+          <a:effectRef idx="0">
+            <a:schemeClr val="accent1"/>
+          </a:effectRef>
+          <a:fontRef idx="minor">
+            <a:schemeClr val="lt1"/>
+          </a:fontRef>
+        </p:style>
+        <p:txBody>
+          <a:bodyPr lIns="36000" tIns="18000" rIns="36000" bIns="18000" rtlCol="0" anchor="ctr">
+            <a:noAutofit/>
+          </a:bodyPr>
+          <a:lstStyle/>
+          <a:p>
+            <a:pPr algn="ctr"/>
+            <a:r>
+              <a:rPr lang="ko-KR" altLang="en-US" sz="900" b="1" dirty="0">
+                <a:solidFill>
+                  <a:schemeClr val="tx1"/>
+                </a:solidFill>
+              </a:rPr>
+              <a:t>Migration Data Selector</a:t>
+            </a:r>
+          </a:p>
+        </p:txBody>
+      </p:sp>
+      <p:sp>
+        <p:nvSpPr>
+          <p:cNvPr id="126" name="Data Object Registry"/>
+          <p:cNvSpPr/>
+          <p:nvPr/>
+        </p:nvSpPr>
+        <p:spPr>
+          <a:xfrm>
+            <a:off x="2200000" y="4780000"/>
+            <a:ext cx="1650000" cy="360000"/>
+          </a:xfrm>
+          <a:prstGeom prst="rect">
+            <a:avLst/>
+          </a:prstGeom>
+          <a:solidFill>
+            <a:schemeClr val="accent4">
+              <a:lumMod val="20000"/>
+              <a:lumOff val="80000"/>
+            </a:schemeClr>
+          </a:solidFill>
+          <a:ln w="12700">
+            <a:solidFill>
+              <a:schemeClr val="tx1"/>
+            </a:solidFill>
+          </a:ln>
+        </p:spPr>
+        <p:style>
+          <a:lnRef idx="2">
+            <a:schemeClr val="accent1">
+              <a:shade val="50000"/>
+            </a:schemeClr>
+          </a:lnRef>
+          <a:fillRef idx="1">
+            <a:schemeClr val="accent1"/>
+          </a:fillRef>
+          <a:effectRef idx="0">
+            <a:schemeClr val="accent1"/>
+          </a:effectRef>
+          <a:fontRef idx="minor">
+            <a:schemeClr val="lt1"/>
+          </a:fontRef>
+        </p:style>
+        <p:txBody>
+          <a:bodyPr lIns="36000" tIns="18000" rIns="36000" bIns="18000" rtlCol="0" anchor="ctr">
+            <a:noAutofit/>
+          </a:bodyPr>
+          <a:lstStyle/>
+          <a:p>
+            <a:pPr algn="ctr"/>
+            <a:r>
+              <a:rPr lang="ko-KR" altLang="en-US" sz="900" b="1" dirty="0">
+                <a:solidFill>
+                  <a:schemeClr val="tx1"/>
+                </a:solidFill>
+              </a:rPr>
+              <a:t>Data Object Registry</a:t>
+            </a:r>
+          </a:p>
+        </p:txBody>
+      </p:sp>
+      <p:sp>
+        <p:nvSpPr>
+          <p:cNvPr id="127" name="Migration Planner / Queue"/>
+          <p:cNvSpPr/>
+          <p:nvPr/>
+        </p:nvSpPr>
+        <p:spPr>
+          <a:xfrm>
+            <a:off x="6500000" y="2780000"/>
+            <a:ext cx="1450000" cy="360000"/>
+          </a:xfrm>
+          <a:prstGeom prst="rect">
+            <a:avLst/>
+          </a:prstGeom>
+          <a:solidFill>
+            <a:schemeClr val="accent4">
+              <a:lumMod val="20000"/>
+              <a:lumOff val="80000"/>
+            </a:schemeClr>
+          </a:solidFill>
+          <a:ln w="12700">
+            <a:solidFill>
+              <a:schemeClr val="tx1"/>
+            </a:solidFill>
+          </a:ln>
+        </p:spPr>
+        <p:style>
+          <a:lnRef idx="2">
+            <a:schemeClr val="accent1">
+              <a:shade val="50000"/>
+            </a:schemeClr>
+          </a:lnRef>
+          <a:fillRef idx="1">
+            <a:schemeClr val="accent1"/>
+          </a:fillRef>
+          <a:effectRef idx="0">
+            <a:schemeClr val="accent1"/>
+          </a:effectRef>
+          <a:fontRef idx="minor">
+            <a:schemeClr val="lt1"/>
+          </a:fontRef>
+        </p:style>
+        <p:txBody>
+          <a:bodyPr lIns="36000" tIns="18000" rIns="36000" bIns="18000" rtlCol="0" anchor="ctr">
+            <a:noAutofit/>
+          </a:bodyPr>
+          <a:lstStyle/>
+          <a:p>
+            <a:pPr algn="ctr"/>
+            <a:r>
+              <a:rPr lang="ko-KR" altLang="en-US" sz="900" b="1" dirty="0">
+                <a:solidFill>
+                  <a:schemeClr val="tx1"/>
+                </a:solidFill>
+              </a:rPr>
+              <a:t>Migration Planner / Queue</a:t>
+            </a:r>
+          </a:p>
+        </p:txBody>
+      </p:sp>
+      <p:sp>
+        <p:nvSpPr>
+          <p:cNvPr id="128" name="Access Guard"/>
+          <p:cNvSpPr/>
+          <p:nvPr/>
+        </p:nvSpPr>
+        <p:spPr>
+          <a:xfrm>
+            <a:off x="6500000" y="3780000"/>
+            <a:ext cx="1450000" cy="360000"/>
+          </a:xfrm>
+          <a:prstGeom prst="rect">
+            <a:avLst/>
+          </a:prstGeom>
+          <a:solidFill>
+            <a:schemeClr val="accent4">
+              <a:lumMod val="20000"/>
+              <a:lumOff val="80000"/>
+            </a:schemeClr>
+          </a:solidFill>
+          <a:ln w="12700">
+            <a:solidFill>
+              <a:schemeClr val="tx1"/>
+            </a:solidFill>
+          </a:ln>
+        </p:spPr>
+        <p:style>
+          <a:lnRef idx="2">
+            <a:schemeClr val="accent1">
+              <a:shade val="50000"/>
+            </a:schemeClr>
+          </a:lnRef>
+          <a:fillRef idx="1">
+            <a:schemeClr val="accent1"/>
+          </a:fillRef>
+          <a:effectRef idx="0">
+            <a:schemeClr val="accent1"/>
+          </a:effectRef>
+          <a:fontRef idx="minor">
+            <a:schemeClr val="lt1"/>
+          </a:fontRef>
+        </p:style>
+        <p:txBody>
+          <a:bodyPr lIns="36000" tIns="18000" rIns="36000" bIns="18000" rtlCol="0" anchor="ctr">
+            <a:noAutofit/>
+          </a:bodyPr>
+          <a:lstStyle/>
+          <a:p>
+            <a:pPr algn="ctr"/>
+            <a:r>
+              <a:rPr lang="ko-KR" altLang="en-US" sz="900" b="1" dirty="0">
+                <a:solidFill>
+                  <a:schemeClr val="tx1"/>
+                </a:solidFill>
+              </a:rPr>
+              <a:t>Access Guard</a:t>
+            </a:r>
+          </a:p>
+          <a:p>
+            <a:pPr algn="ctr"/>
+            <a:r>
+              <a:rPr lang="ko-KR" altLang="en-US" sz="750" dirty="0">
+                <a:solidFill>
+                  <a:schemeClr val="tx1"/>
+                </a:solidFill>
+              </a:rPr>
+              <a:t>(pin · epoch)</a:t>
+            </a:r>
+          </a:p>
+        </p:txBody>
+      </p:sp>
+      <p:sp>
+        <p:nvSpPr>
+          <p:cNvPr id="129" name="Data Location Store"/>
+          <p:cNvSpPr/>
+          <p:nvPr/>
+        </p:nvSpPr>
+        <p:spPr>
+          <a:xfrm>
+            <a:off x="6500000" y="4280000"/>
+            <a:ext cx="1450000" cy="360000"/>
+          </a:xfrm>
+          <a:prstGeom prst="rect">
+            <a:avLst/>
+          </a:prstGeom>
+          <a:solidFill>
+            <a:schemeClr val="accent4">
+              <a:lumMod val="20000"/>
+              <a:lumOff val="80000"/>
+            </a:schemeClr>
+          </a:solidFill>
+          <a:ln w="12700">
+            <a:solidFill>
+              <a:schemeClr val="tx1"/>
+            </a:solidFill>
+          </a:ln>
+        </p:spPr>
+        <p:style>
+          <a:lnRef idx="2">
+            <a:schemeClr val="accent1">
+              <a:shade val="50000"/>
+            </a:schemeClr>
+          </a:lnRef>
+          <a:fillRef idx="1">
+            <a:schemeClr val="accent1"/>
+          </a:fillRef>
+          <a:effectRef idx="0">
+            <a:schemeClr val="accent1"/>
+          </a:effectRef>
+          <a:fontRef idx="minor">
+            <a:schemeClr val="lt1"/>
+          </a:fontRef>
+        </p:style>
+        <p:txBody>
+          <a:bodyPr lIns="36000" tIns="18000" rIns="36000" bIns="18000" rtlCol="0" anchor="ctr">
+            <a:noAutofit/>
+          </a:bodyPr>
+          <a:lstStyle/>
+          <a:p>
+            <a:pPr algn="ctr"/>
+            <a:r>
+              <a:rPr lang="ko-KR" altLang="en-US" sz="900" b="1" dirty="0">
+                <a:solidFill>
+                  <a:schemeClr val="tx1"/>
+                </a:solidFill>
+              </a:rPr>
+              <a:t>Data Location Store</a:t>
+            </a:r>
+          </a:p>
+          <a:p>
+            <a:pPr algn="ctr"/>
+            <a:r>
+              <a:rPr lang="ko-KR" altLang="en-US" sz="750" dirty="0">
+                <a:solidFill>
+                  <a:schemeClr val="tx1"/>
+                </a:solidFill>
+              </a:rPr>
+              <a:t>(authoritative)</a:t>
+            </a:r>
+          </a:p>
+        </p:txBody>
+      </p:sp>
+      <p:sp>
+        <p:nvSpPr>
+          <p:cNvPr id="130" name="Migration Coordinator"/>
+          <p:cNvSpPr/>
+          <p:nvPr/>
+        </p:nvSpPr>
+        <p:spPr>
+          <a:xfrm>
+            <a:off x="4950000" y="4280000"/>
+            <a:ext cx="1450000" cy="360000"/>
+          </a:xfrm>
+          <a:prstGeom prst="rect">
+            <a:avLst/>
+          </a:prstGeom>
+          <a:solidFill>
+            <a:schemeClr val="accent4">
+              <a:lumMod val="20000"/>
+              <a:lumOff val="80000"/>
+            </a:schemeClr>
+          </a:solidFill>
+          <a:ln w="12700">
+            <a:solidFill>
+              <a:schemeClr val="tx1"/>
+            </a:solidFill>
+          </a:ln>
+        </p:spPr>
+        <p:style>
+          <a:lnRef idx="2">
+            <a:schemeClr val="accent1">
+              <a:shade val="50000"/>
+            </a:schemeClr>
+          </a:lnRef>
+          <a:fillRef idx="1">
+            <a:schemeClr val="accent1"/>
+          </a:fillRef>
+          <a:effectRef idx="0">
+            <a:schemeClr val="accent1"/>
+          </a:effectRef>
+          <a:fontRef idx="minor">
+            <a:schemeClr val="lt1"/>
+          </a:fontRef>
+        </p:style>
+        <p:txBody>
+          <a:bodyPr lIns="36000" tIns="18000" rIns="36000" bIns="18000" rtlCol="0" anchor="ctr">
+            <a:noAutofit/>
+          </a:bodyPr>
+          <a:lstStyle/>
+          <a:p>
+            <a:pPr algn="ctr"/>
+            <a:r>
+              <a:rPr lang="ko-KR" altLang="en-US" sz="900" b="1" dirty="0">
+                <a:solidFill>
+                  <a:schemeClr val="tx1"/>
+                </a:solidFill>
+              </a:rPr>
+              <a:t>Migration Coordinator</a:t>
+            </a:r>
+          </a:p>
+        </p:txBody>
+      </p:sp>
+      <p:sp>
+        <p:nvSpPr>
+          <p:cNvPr id="131" name="Completion Reconciler"/>
+          <p:cNvSpPr/>
+          <p:nvPr/>
+        </p:nvSpPr>
+        <p:spPr>
+          <a:xfrm>
+            <a:off x="4950000" y="4780000"/>
+            <a:ext cx="1450000" cy="360000"/>
+          </a:xfrm>
+          <a:prstGeom prst="rect">
+            <a:avLst/>
+          </a:prstGeom>
+          <a:solidFill>
+            <a:schemeClr val="accent4">
+              <a:lumMod val="20000"/>
+              <a:lumOff val="80000"/>
+            </a:schemeClr>
+          </a:solidFill>
+          <a:ln w="12700">
+            <a:solidFill>
+              <a:schemeClr val="tx1"/>
+            </a:solidFill>
+          </a:ln>
+        </p:spPr>
+        <p:style>
+          <a:lnRef idx="2">
+            <a:schemeClr val="accent1">
+              <a:shade val="50000"/>
+            </a:schemeClr>
+          </a:lnRef>
+          <a:fillRef idx="1">
+            <a:schemeClr val="accent1"/>
+          </a:fillRef>
+          <a:effectRef idx="0">
+            <a:schemeClr val="accent1"/>
+          </a:effectRef>
+          <a:fontRef idx="minor">
+            <a:schemeClr val="lt1"/>
+          </a:fontRef>
+        </p:style>
+        <p:txBody>
+          <a:bodyPr lIns="36000" tIns="18000" rIns="36000" bIns="18000" rtlCol="0" anchor="ctr">
+            <a:noAutofit/>
+          </a:bodyPr>
+          <a:lstStyle/>
+          <a:p>
+            <a:pPr algn="ctr"/>
+            <a:r>
+              <a:rPr lang="ko-KR" altLang="en-US" sz="900" b="1" dirty="0">
+                <a:solidFill>
+                  <a:schemeClr val="tx1"/>
+                </a:solidFill>
+              </a:rPr>
+              <a:t>Completion Reconciler</a:t>
+            </a:r>
+          </a:p>
+        </p:txBody>
+      </p:sp>
+      <p:sp>
+        <p:nvSpPr>
+          <p:cNvPr id="132" name="Migration Executor"/>
+          <p:cNvSpPr/>
+          <p:nvPr/>
+        </p:nvSpPr>
+        <p:spPr>
+          <a:xfrm>
+            <a:off x="8850000" y="2780000"/>
+            <a:ext cx="2850000" cy="360000"/>
+          </a:xfrm>
+          <a:prstGeom prst="rect">
+            <a:avLst/>
+          </a:prstGeom>
+          <a:solidFill>
+            <a:schemeClr val="accent4">
+              <a:lumMod val="20000"/>
+              <a:lumOff val="80000"/>
+            </a:schemeClr>
+          </a:solidFill>
+          <a:ln w="12700">
+            <a:solidFill>
+              <a:schemeClr val="tx1"/>
+            </a:solidFill>
+          </a:ln>
+        </p:spPr>
+        <p:style>
+          <a:lnRef idx="2">
+            <a:schemeClr val="accent1">
+              <a:shade val="50000"/>
+            </a:schemeClr>
+          </a:lnRef>
+          <a:fillRef idx="1">
+            <a:schemeClr val="accent1"/>
+          </a:fillRef>
+          <a:effectRef idx="0">
+            <a:schemeClr val="accent1"/>
+          </a:effectRef>
+          <a:fontRef idx="minor">
+            <a:schemeClr val="lt1"/>
+          </a:fontRef>
+        </p:style>
+        <p:txBody>
+          <a:bodyPr lIns="36000" tIns="18000" rIns="36000" bIns="18000" rtlCol="0" anchor="ctr">
+            <a:noAutofit/>
+          </a:bodyPr>
           <a:lstStyle/>
           <a:p>
             <a:pPr algn="ctr"/>
@@ -6851,8 +7020,8 @@
         </p:nvSpPr>
         <p:spPr>
           <a:xfrm>
-            <a:off x="10020000" y="3900000"/>
-            <a:ext cx="1550000" cy="360000"/>
+            <a:off x="10050000" y="3780000"/>
+            <a:ext cx="1650000" cy="360000"/>
           </a:xfrm>
           <a:prstGeom prst="rect">
             <a:avLst/>
@@ -6863,24 +7032,32 @@
               <a:lumOff val="80000"/>
             </a:schemeClr>
           </a:solidFill>
-          <a:ln/>
+          <a:ln w="12700">
+            <a:solidFill>
+              <a:schemeClr val="tx1"/>
+            </a:solidFill>
+          </a:ln>
         </p:spPr>
         <p:style>
           <a:lnRef idx="2">
-            <a:schemeClr val="dk1"/>
+            <a:schemeClr val="accent1">
+              <a:shade val="50000"/>
+            </a:schemeClr>
           </a:lnRef>
           <a:fillRef idx="1">
-            <a:schemeClr val="lt1"/>
+            <a:schemeClr val="accent1"/>
           </a:fillRef>
           <a:effectRef idx="0">
-            <a:schemeClr val="dk1"/>
+            <a:schemeClr val="accent1"/>
           </a:effectRef>
           <a:fontRef idx="minor">
-            <a:schemeClr val="dk1"/>
+            <a:schemeClr val="lt1"/>
           </a:fontRef>
         </p:style>
         <p:txBody>
-          <a:bodyPr lIns="36000" rIns="36000" tIns="18000" bIns="18000" rtlCol="0" anchor="ctr"/>
+          <a:bodyPr lIns="36000" tIns="18000" rIns="36000" bIns="18000" rtlCol="0" anchor="ctr">
+            <a:noAutofit/>
+          </a:bodyPr>
           <a:lstStyle/>
           <a:p>
             <a:pPr algn="ctr"/>
@@ -6904,7 +7081,7 @@
         <p:spPr>
           <a:xfrm>
             <a:off x="400000" y="5800000"/>
-            <a:ext cx="11400000" cy="650000"/>
+            <a:ext cx="11400000" cy="620000"/>
           </a:xfrm>
           <a:prstGeom prst="rect">
             <a:avLst/>
@@ -6938,7 +7115,9 @@
           </a:fontRef>
         </p:style>
         <p:txBody>
-          <a:bodyPr rtlCol="0" anchor="t"/>
+          <a:bodyPr lIns="36000" tIns="18000" rIns="36000" bIns="0" rtlCol="0" anchor="t">
+            <a:noAutofit/>
+          </a:bodyPr>
           <a:lstStyle/>
           <a:p>
             <a:pPr algn="ctr"/>
@@ -6996,10 +7175,12 @@
           </a:fontRef>
         </p:style>
         <p:txBody>
-          <a:bodyPr rtlCol="0" anchor="ctr"/>
-          <a:lstStyle/>
-          <a:p>
-            <a:endParaRPr lang="ko-KR" altLang="en-US"/>
+          <a:bodyPr lIns="36000" tIns="18000" rIns="36000" bIns="18000" rtlCol="0" anchor="ctr">
+            <a:noAutofit/>
+          </a:bodyPr>
+          <a:lstStyle/>
+          <a:p>
+            <a:endParaRPr lang="ko-KR"/>
           </a:p>
         </p:txBody>
       </p:sp>
@@ -7012,7 +7193,7 @@
         <p:spPr>
           <a:xfrm>
             <a:off x="550000" y="6070000"/>
-            <a:ext cx="5950000" cy="310000"/>
+            <a:ext cx="5950000" cy="300000"/>
           </a:xfrm>
           <a:prstGeom prst="rect">
             <a:avLst/>
@@ -7023,24 +7204,32 @@
               <a:lumOff val="80000"/>
             </a:schemeClr>
           </a:solidFill>
-          <a:ln/>
+          <a:ln w="12700">
+            <a:solidFill>
+              <a:schemeClr val="tx1"/>
+            </a:solidFill>
+          </a:ln>
         </p:spPr>
         <p:style>
           <a:lnRef idx="2">
-            <a:schemeClr val="dk1"/>
+            <a:schemeClr val="accent1">
+              <a:shade val="50000"/>
+            </a:schemeClr>
           </a:lnRef>
           <a:fillRef idx="1">
-            <a:schemeClr val="lt1"/>
+            <a:schemeClr val="accent1"/>
           </a:fillRef>
           <a:effectRef idx="0">
-            <a:schemeClr val="dk1"/>
+            <a:schemeClr val="accent1"/>
           </a:effectRef>
           <a:fontRef idx="minor">
-            <a:schemeClr val="dk1"/>
+            <a:schemeClr val="lt1"/>
           </a:fontRef>
         </p:style>
         <p:txBody>
-          <a:bodyPr lIns="36000" rIns="36000" tIns="18000" bIns="18000" rtlCol="0" anchor="ctr"/>
+          <a:bodyPr lIns="36000" tIns="18000" rIns="36000" bIns="18000" rtlCol="0" anchor="ctr">
+            <a:noAutofit/>
+          </a:bodyPr>
           <a:lstStyle/>
           <a:p>
             <a:pPr algn="ctr"/>
@@ -7063,8 +7252,8 @@
         </p:nvSpPr>
         <p:spPr>
           <a:xfrm>
-            <a:off x="8880000" y="6070000"/>
-            <a:ext cx="2690000" cy="310000"/>
+            <a:off x="8850000" y="6070000"/>
+            <a:ext cx="2850000" cy="300000"/>
           </a:xfrm>
           <a:prstGeom prst="rect">
             <a:avLst/>
@@ -7075,24 +7264,32 @@
               <a:lumOff val="80000"/>
             </a:schemeClr>
           </a:solidFill>
-          <a:ln/>
+          <a:ln w="12700">
+            <a:solidFill>
+              <a:schemeClr val="tx1"/>
+            </a:solidFill>
+          </a:ln>
         </p:spPr>
         <p:style>
           <a:lnRef idx="2">
-            <a:schemeClr val="dk1"/>
+            <a:schemeClr val="accent1">
+              <a:shade val="50000"/>
+            </a:schemeClr>
           </a:lnRef>
           <a:fillRef idx="1">
-            <a:schemeClr val="lt1"/>
+            <a:schemeClr val="accent1"/>
           </a:fillRef>
           <a:effectRef idx="0">
-            <a:schemeClr val="dk1"/>
+            <a:schemeClr val="accent1"/>
           </a:effectRef>
           <a:fontRef idx="minor">
-            <a:schemeClr val="dk1"/>
+            <a:schemeClr val="lt1"/>
           </a:fontRef>
         </p:style>
         <p:txBody>
-          <a:bodyPr lIns="36000" rIns="36000" tIns="18000" bIns="18000" rtlCol="0" anchor="ctr"/>
+          <a:bodyPr lIns="36000" tIns="18000" rIns="36000" bIns="18000" rtlCol="0" anchor="ctr">
+            <a:noAutofit/>
+          </a:bodyPr>
           <a:lstStyle/>
           <a:p>
             <a:pPr algn="ctr"/>
@@ -7115,8 +7312,8 @@
         </p:nvSpPr>
         <p:spPr>
           <a:xfrm>
-            <a:off x="600000" y="2840000"/>
-            <a:ext cx="3250000" cy="2520000"/>
+            <a:off x="450000" y="2700000"/>
+            <a:ext cx="3450000" cy="2520000"/>
           </a:xfrm>
           <a:prstGeom prst="rect">
             <a:avLst/>
@@ -7146,10 +7343,12 @@
           </a:fontRef>
         </p:style>
         <p:txBody>
-          <a:bodyPr rtlCol="0" anchor="ctr"/>
-          <a:lstStyle/>
-          <a:p>
-            <a:endParaRPr lang="ko-KR" altLang="en-US"/>
+          <a:bodyPr lIns="36000" tIns="18000" rIns="36000" bIns="18000" rtlCol="0" anchor="ctr">
+            <a:noAutofit/>
+          </a:bodyPr>
+          <a:lstStyle/>
+          <a:p>
+            <a:endParaRPr lang="ko-KR"/>
           </a:p>
         </p:txBody>
       </p:sp>
@@ -7161,8 +7360,8 @@
         </p:nvSpPr>
         <p:spPr>
           <a:xfrm>
-            <a:off x="5000000" y="2840000"/>
-            <a:ext cx="2800000" cy="2520000"/>
+            <a:off x="4900000" y="2700000"/>
+            <a:ext cx="3100000" cy="2520000"/>
           </a:xfrm>
           <a:prstGeom prst="rect">
             <a:avLst/>
@@ -7192,10 +7391,12 @@
           </a:fontRef>
         </p:style>
         <p:txBody>
-          <a:bodyPr rtlCol="0" anchor="ctr"/>
-          <a:lstStyle/>
-          <a:p>
-            <a:endParaRPr lang="ko-KR" altLang="en-US"/>
+          <a:bodyPr lIns="36000" tIns="18000" rIns="36000" bIns="18000" rtlCol="0" anchor="ctr">
+            <a:noAutofit/>
+          </a:bodyPr>
+          <a:lstStyle/>
+          <a:p>
+            <a:endParaRPr lang="ko-KR"/>
           </a:p>
         </p:txBody>
       </p:sp>
@@ -7207,8 +7408,8 @@
         </p:nvSpPr>
         <p:spPr>
           <a:xfrm>
-            <a:off x="8840000" y="2840000"/>
-            <a:ext cx="2770000" cy="1480000"/>
+            <a:off x="8800000" y="2700000"/>
+            <a:ext cx="2950000" cy="1520000"/>
           </a:xfrm>
           <a:prstGeom prst="rect">
             <a:avLst/>
@@ -7238,10 +7439,12 @@
           </a:fontRef>
         </p:style>
         <p:txBody>
-          <a:bodyPr rtlCol="0" anchor="ctr"/>
-          <a:lstStyle/>
-          <a:p>
-            <a:endParaRPr lang="ko-KR" altLang="en-US"/>
+          <a:bodyPr lIns="36000" tIns="18000" rIns="36000" bIns="18000" rtlCol="0" anchor="ctr">
+            <a:noAutofit/>
+          </a:bodyPr>
+          <a:lstStyle/>
+          <a:p>
+            <a:endParaRPr lang="ko-KR"/>
           </a:p>
         </p:txBody>
       </p:sp>
@@ -7253,8 +7456,8 @@
         </p:nvSpPr>
         <p:spPr>
           <a:xfrm>
-            <a:off x="4980000" y="1740000"/>
-            <a:ext cx="1350000" cy="460000"/>
+            <a:off x="6450000" y="1600000"/>
+            <a:ext cx="1550000" cy="420000"/>
           </a:xfrm>
           <a:prstGeom prst="rect">
             <a:avLst/>
@@ -7284,23 +7487,25 @@
           </a:fontRef>
         </p:style>
         <p:txBody>
-          <a:bodyPr rtlCol="0" anchor="ctr"/>
-          <a:lstStyle/>
-          <a:p>
-            <a:endParaRPr lang="ko-KR" altLang="en-US"/>
-          </a:p>
-        </p:txBody>
-      </p:sp>
-      <p:sp>
-        <p:nvSpPr>
-          <p:cNvPr id="142" name="DP5 수정 Worker Model Runner"/>
+          <a:bodyPr lIns="36000" tIns="18000" rIns="36000" bIns="18000" rtlCol="0" anchor="ctr">
+            <a:noAutofit/>
+          </a:bodyPr>
+          <a:lstStyle/>
+          <a:p>
+            <a:endParaRPr lang="ko-KR"/>
+          </a:p>
+        </p:txBody>
+      </p:sp>
+      <p:sp>
+        <p:nvSpPr>
+          <p:cNvPr id="142" name="DP5 수정 Model Runner"/>
           <p:cNvSpPr/>
           <p:nvPr/>
         </p:nvSpPr>
         <p:spPr>
           <a:xfrm>
-            <a:off x="8840000" y="1740000"/>
-            <a:ext cx="2770000" cy="460000"/>
+            <a:off x="9800000" y="1600000"/>
+            <a:ext cx="1950000" cy="420000"/>
           </a:xfrm>
           <a:prstGeom prst="rect">
             <a:avLst/>
@@ -7330,10 +7535,12 @@
           </a:fontRef>
         </p:style>
         <p:txBody>
-          <a:bodyPr rtlCol="0" anchor="ctr"/>
-          <a:lstStyle/>
-          <a:p>
-            <a:endParaRPr lang="ko-KR" altLang="en-US"/>
+          <a:bodyPr lIns="36000" tIns="18000" rIns="36000" bIns="18000" rtlCol="0" anchor="ctr">
+            <a:noAutofit/>
+          </a:bodyPr>
+          <a:lstStyle/>
+          <a:p>
+            <a:endParaRPr lang="ko-KR"/>
           </a:p>
         </p:txBody>
       </p:sp>
@@ -7346,7 +7553,7 @@
         <p:spPr>
           <a:xfrm>
             <a:off x="480000" y="6030000"/>
-            <a:ext cx="6100000" cy="390000"/>
+            <a:ext cx="6100000" cy="380000"/>
           </a:xfrm>
           <a:prstGeom prst="rect">
             <a:avLst/>
@@ -7376,10 +7583,12 @@
           </a:fontRef>
         </p:style>
         <p:txBody>
-          <a:bodyPr rtlCol="0" anchor="ctr"/>
-          <a:lstStyle/>
-          <a:p>
-            <a:endParaRPr lang="ko-KR" altLang="en-US"/>
+          <a:bodyPr lIns="36000" tIns="18000" rIns="36000" bIns="18000" rtlCol="0" anchor="ctr">
+            <a:noAutofit/>
+          </a:bodyPr>
+          <a:lstStyle/>
+          <a:p>
+            <a:endParaRPr lang="ko-KR"/>
           </a:p>
         </p:txBody>
       </p:sp>
@@ -7391,8 +7600,8 @@
         </p:nvSpPr>
         <p:spPr>
           <a:xfrm>
-            <a:off x="8820000" y="6030000"/>
-            <a:ext cx="2810000" cy="390000"/>
+            <a:off x="8800000" y="6030000"/>
+            <a:ext cx="2950000" cy="380000"/>
           </a:xfrm>
           <a:prstGeom prst="rect">
             <a:avLst/>
@@ -7422,252 +7631,152 @@
           </a:fontRef>
         </p:style>
         <p:txBody>
-          <a:bodyPr rtlCol="0" anchor="ctr"/>
-          <a:lstStyle/>
-          <a:p>
-            <a:endParaRPr lang="ko-KR" altLang="en-US"/>
+          <a:bodyPr lIns="36000" tIns="18000" rIns="36000" bIns="18000" rtlCol="0" anchor="ctr">
+            <a:noAutofit/>
+          </a:bodyPr>
+          <a:lstStyle/>
+          <a:p>
+            <a:endParaRPr lang="ko-KR"/>
           </a:p>
         </p:txBody>
       </p:sp>
       <p:cxnSp>
         <p:nvCxnSpPr>
-          <p:cNvPr id="145" name="DP1 flow 1"/>
-          <p:cNvCxnSpPr>
-            <a:cxnSpLocks/>
-          </p:cNvCxnSpPr>
+          <p:cNvPr id="145" name="flow 0"/>
+          <p:cNvCxnSpPr/>
           <p:nvPr/>
         </p:nvCxnSpPr>
         <p:spPr>
           <a:xfrm>
-            <a:off x="1375000" y="3260000"/>
+            <a:off x="1325000" y="3140000"/>
             <a:ext cx="0" cy="140000"/>
           </a:xfrm>
-          <a:prstGeom prst="straightConnector1">
-            <a:avLst/>
-          </a:prstGeom>
-          <a:ln>
+          <a:prstGeom prst="line">
+            <a:avLst/>
+          </a:prstGeom>
+          <a:ln w="12700">
             <a:solidFill>
               <a:schemeClr val="tx1"/>
             </a:solidFill>
             <a:prstDash val="dash"/>
-            <a:headEnd type="none" w="med" len="med"/>
-            <a:tailEnd type="arrow" w="med" len="med"/>
+            <a:tailEnd type="arrow"/>
           </a:ln>
         </p:spPr>
-        <p:style>
-          <a:lnRef idx="1">
-            <a:schemeClr val="accent1"/>
-          </a:lnRef>
-          <a:fillRef idx="0">
-            <a:schemeClr val="accent1"/>
-          </a:fillRef>
-          <a:effectRef idx="0">
-            <a:schemeClr val="accent1"/>
-          </a:effectRef>
-          <a:fontRef idx="minor">
-            <a:schemeClr val="tx1"/>
-          </a:fontRef>
-        </p:style>
       </p:cxnSp>
       <p:cxnSp>
         <p:nvCxnSpPr>
-          <p:cNvPr id="146" name="DP1 flow 2"/>
-          <p:cNvCxnSpPr>
-            <a:cxnSpLocks/>
-          </p:cNvCxnSpPr>
+          <p:cNvPr id="146" name="flow 1"/>
+          <p:cNvCxnSpPr/>
           <p:nvPr/>
         </p:nvCxnSpPr>
         <p:spPr>
           <a:xfrm>
-            <a:off x="1375000" y="3760000"/>
+            <a:off x="1325000" y="3640000"/>
             <a:ext cx="0" cy="140000"/>
           </a:xfrm>
-          <a:prstGeom prst="straightConnector1">
-            <a:avLst/>
-          </a:prstGeom>
-          <a:ln>
+          <a:prstGeom prst="line">
+            <a:avLst/>
+          </a:prstGeom>
+          <a:ln w="12700">
             <a:solidFill>
               <a:schemeClr val="tx1"/>
             </a:solidFill>
             <a:prstDash val="dash"/>
-            <a:headEnd type="none" w="med" len="med"/>
-            <a:tailEnd type="arrow" w="med" len="med"/>
+            <a:tailEnd type="arrow"/>
           </a:ln>
         </p:spPr>
-        <p:style>
-          <a:lnRef idx="1">
-            <a:schemeClr val="accent1"/>
-          </a:lnRef>
-          <a:fillRef idx="0">
-            <a:schemeClr val="accent1"/>
-          </a:fillRef>
-          <a:effectRef idx="0">
-            <a:schemeClr val="accent1"/>
-          </a:effectRef>
-          <a:fontRef idx="minor">
-            <a:schemeClr val="tx1"/>
-          </a:fontRef>
-        </p:style>
       </p:cxnSp>
       <p:cxnSp>
         <p:nvCxnSpPr>
-          <p:cNvPr id="147" name="DP1 flow 3"/>
-          <p:cNvCxnSpPr>
-            <a:cxnSpLocks/>
-          </p:cNvCxnSpPr>
+          <p:cNvPr id="147" name="flow 2"/>
+          <p:cNvCxnSpPr/>
           <p:nvPr/>
         </p:nvCxnSpPr>
         <p:spPr>
           <a:xfrm>
-            <a:off x="1375000" y="4260000"/>
+            <a:off x="1325000" y="4140000"/>
             <a:ext cx="0" cy="140000"/>
           </a:xfrm>
-          <a:prstGeom prst="straightConnector1">
-            <a:avLst/>
-          </a:prstGeom>
-          <a:ln>
+          <a:prstGeom prst="line">
+            <a:avLst/>
+          </a:prstGeom>
+          <a:ln w="12700">
             <a:solidFill>
               <a:schemeClr val="tx1"/>
             </a:solidFill>
             <a:prstDash val="dash"/>
-            <a:headEnd type="none" w="med" len="med"/>
-            <a:tailEnd type="arrow" w="med" len="med"/>
+            <a:tailEnd type="arrow"/>
           </a:ln>
         </p:spPr>
-        <p:style>
-          <a:lnRef idx="1">
-            <a:schemeClr val="accent1"/>
-          </a:lnRef>
-          <a:fillRef idx="0">
-            <a:schemeClr val="accent1"/>
-          </a:fillRef>
-          <a:effectRef idx="0">
-            <a:schemeClr val="accent1"/>
-          </a:effectRef>
-          <a:fontRef idx="minor">
-            <a:schemeClr val="tx1"/>
-          </a:fontRef>
-        </p:style>
       </p:cxnSp>
       <p:cxnSp>
         <p:nvCxnSpPr>
-          <p:cNvPr id="148" name="DP1 flow 4"/>
-          <p:cNvCxnSpPr>
-            <a:cxnSpLocks/>
-          </p:cNvCxnSpPr>
+          <p:cNvPr id="148" name="flow 4"/>
+          <p:cNvCxnSpPr/>
           <p:nvPr/>
         </p:nvCxnSpPr>
         <p:spPr>
           <a:xfrm>
-            <a:off x="1375000" y="4760000"/>
+            <a:off x="1325000" y="4640000"/>
             <a:ext cx="0" cy="140000"/>
           </a:xfrm>
-          <a:prstGeom prst="straightConnector1">
-            <a:avLst/>
-          </a:prstGeom>
-          <a:ln>
+          <a:prstGeom prst="line">
+            <a:avLst/>
+          </a:prstGeom>
+          <a:ln w="12700">
             <a:solidFill>
               <a:schemeClr val="tx1"/>
             </a:solidFill>
             <a:prstDash val="dash"/>
-            <a:headEnd type="none" w="med" len="med"/>
-            <a:tailEnd type="arrow" w="med" len="med"/>
+            <a:tailEnd type="arrow"/>
           </a:ln>
         </p:spPr>
-        <p:style>
-          <a:lnRef idx="1">
-            <a:schemeClr val="accent1"/>
-          </a:lnRef>
-          <a:fillRef idx="0">
-            <a:schemeClr val="accent1"/>
-          </a:fillRef>
-          <a:effectRef idx="0">
-            <a:schemeClr val="accent1"/>
-          </a:effectRef>
-          <a:fontRef idx="minor">
-            <a:schemeClr val="tx1"/>
-          </a:fontRef>
-        </p:style>
       </p:cxnSp>
       <p:cxnSp>
         <p:nvCxnSpPr>
           <p:cNvPr id="149" name="DTS to MDS"/>
-          <p:cNvCxnSpPr>
-            <a:cxnSpLocks/>
-          </p:cNvCxnSpPr>
+          <p:cNvCxnSpPr/>
           <p:nvPr/>
         </p:nvCxnSpPr>
         <p:spPr>
           <a:xfrm>
-            <a:off x="2100000" y="4580000"/>
-            <a:ext cx="250000" cy="0"/>
-          </a:xfrm>
-          <a:prstGeom prst="straightConnector1">
-            <a:avLst/>
-          </a:prstGeom>
-          <a:ln>
+            <a:off x="2150000" y="4460000"/>
+            <a:ext cx="50000" cy="0"/>
+          </a:xfrm>
+          <a:prstGeom prst="line">
+            <a:avLst/>
+          </a:prstGeom>
+          <a:ln w="12700">
             <a:solidFill>
               <a:schemeClr val="tx1"/>
             </a:solidFill>
             <a:prstDash val="dash"/>
-            <a:headEnd type="none" w="med" len="med"/>
-            <a:tailEnd type="arrow" w="med" len="med"/>
+            <a:tailEnd type="arrow"/>
           </a:ln>
         </p:spPr>
-        <p:style>
-          <a:lnRef idx="1">
-            <a:schemeClr val="accent1"/>
-          </a:lnRef>
-          <a:fillRef idx="0">
-            <a:schemeClr val="accent1"/>
-          </a:fillRef>
-          <a:effectRef idx="0">
-            <a:schemeClr val="accent1"/>
-          </a:effectRef>
-          <a:fontRef idx="minor">
-            <a:schemeClr val="tx1"/>
-          </a:fontRef>
-        </p:style>
       </p:cxnSp>
       <p:cxnSp>
         <p:nvCxnSpPr>
           <p:cNvPr id="150" name="③ binding"/>
-          <p:cNvCxnSpPr>
-            <a:cxnSpLocks/>
-          </p:cNvCxnSpPr>
+          <p:cNvCxnSpPr/>
           <p:nvPr/>
         </p:nvCxnSpPr>
         <p:spPr>
           <a:xfrm flipV="1">
-            <a:off x="3800000" y="3030000"/>
-            <a:ext cx="2700000" cy="50000"/>
-          </a:xfrm>
-          <a:prstGeom prst="straightConnector1">
-            <a:avLst/>
-          </a:prstGeom>
-          <a:ln>
+            <a:off x="3850000" y="2910000"/>
+            <a:ext cx="2650000" cy="50000"/>
+          </a:xfrm>
+          <a:prstGeom prst="line">
+            <a:avLst/>
+          </a:prstGeom>
+          <a:ln w="12700">
             <a:solidFill>
               <a:schemeClr val="tx1"/>
             </a:solidFill>
             <a:prstDash val="dash"/>
-            <a:headEnd type="none" w="med" len="med"/>
-            <a:tailEnd type="arrow" w="med" len="med"/>
+            <a:tailEnd type="arrow"/>
           </a:ln>
         </p:spPr>
-        <p:style>
-          <a:lnRef idx="1">
-            <a:schemeClr val="accent1"/>
-          </a:lnRef>
-          <a:fillRef idx="0">
-            <a:schemeClr val="accent1"/>
-          </a:fillRef>
-          <a:effectRef idx="0">
-            <a:schemeClr val="accent1"/>
-          </a:effectRef>
-          <a:fontRef idx="minor">
-            <a:schemeClr val="tx1"/>
-          </a:fontRef>
-        </p:style>
       </p:cxnSp>
       <p:sp>
         <p:nvSpPr>
@@ -7677,8 +7786,8 @@
         </p:nvSpPr>
         <p:spPr>
           <a:xfrm>
-            <a:off x="3930000" y="2740000"/>
-            <a:ext cx="980000" cy="300000"/>
+            <a:off x="3970000" y="2600000"/>
+            <a:ext cx="860000" cy="320000"/>
           </a:xfrm>
           <a:prstGeom prst="rect">
             <a:avLst/>
@@ -7698,7 +7807,7 @@
                   <a:schemeClr val="tx1"/>
                 </a:solidFill>
               </a:rPr>
-              <a:t>③ binding · topology</a:t>
+              <a:t>③ binding ·</a:t>
             </a:r>
           </a:p>
           <a:p>
@@ -7709,7 +7818,7 @@
                   <a:schemeClr val="tx1"/>
                 </a:solidFill>
               </a:rPr>
-              <a:t>(읽기 전용)</a:t>
+              <a:t>topology (읽기)</a:t>
             </a:r>
           </a:p>
         </p:txBody>
@@ -7717,17 +7826,15 @@
       <p:cxnSp>
         <p:nvCxnSpPr>
           <p:cNvPr id="152" name="② MigrationIntent"/>
-          <p:cNvCxnSpPr>
-            <a:cxnSpLocks/>
-          </p:cNvCxnSpPr>
+          <p:cNvCxnSpPr/>
           <p:nvPr/>
         </p:nvCxnSpPr>
         <p:spPr>
           <a:xfrm>
-            <a:off x="3800000" y="4580000"/>
-            <a:ext cx="1230000" cy="0"/>
-          </a:xfrm>
-          <a:prstGeom prst="straightConnector1">
+            <a:off x="3850000" y="4460000"/>
+            <a:ext cx="1100000" cy="0"/>
+          </a:xfrm>
+          <a:prstGeom prst="line">
             <a:avLst/>
           </a:prstGeom>
           <a:ln w="28575">
@@ -7735,24 +7842,9 @@
               <a:schemeClr val="tx1"/>
             </a:solidFill>
             <a:prstDash val="dash"/>
-            <a:headEnd type="none" w="med" len="med"/>
-            <a:tailEnd type="arrow" w="med" len="med"/>
+            <a:tailEnd type="arrow"/>
           </a:ln>
         </p:spPr>
-        <p:style>
-          <a:lnRef idx="1">
-            <a:schemeClr val="accent1"/>
-          </a:lnRef>
-          <a:fillRef idx="0">
-            <a:schemeClr val="accent1"/>
-          </a:fillRef>
-          <a:effectRef idx="0">
-            <a:schemeClr val="accent1"/>
-          </a:effectRef>
-          <a:fontRef idx="minor">
-            <a:schemeClr val="tx1"/>
-          </a:fontRef>
-        </p:style>
       </p:cxnSp>
       <p:sp>
         <p:nvSpPr>
@@ -7762,8 +7854,8 @@
         </p:nvSpPr>
         <p:spPr>
           <a:xfrm>
-            <a:off x="3930000" y="4280000"/>
-            <a:ext cx="980000" cy="260000"/>
+            <a:off x="3970000" y="4120000"/>
+            <a:ext cx="860000" cy="300000"/>
           </a:xfrm>
           <a:prstGeom prst="rect">
             <a:avLst/>
@@ -7778,12 +7870,23 @@
           <a:p>
             <a:pPr algn="ctr"/>
             <a:r>
-              <a:rPr lang="ko-KR" altLang="en-US" sz="800" b="1" dirty="0">
+              <a:rPr lang="ko-KR" altLang="en-US" sz="750" b="1" dirty="0">
                 <a:solidFill>
                   <a:schemeClr val="tx1"/>
                 </a:solidFill>
               </a:rPr>
-              <a:t>② MigrationIntent</a:t>
+              <a:t>② Migration</a:t>
+            </a:r>
+          </a:p>
+          <a:p>
+            <a:pPr algn="ctr"/>
+            <a:r>
+              <a:rPr lang="ko-KR" altLang="en-US" sz="750" b="1" dirty="0">
+                <a:solidFill>
+                  <a:schemeClr val="tx1"/>
+                </a:solidFill>
+              </a:rPr>
+              <a:t>Intent</a:t>
             </a:r>
           </a:p>
         </p:txBody>
@@ -7791,42 +7894,25 @@
       <p:cxnSp>
         <p:nvCxnSpPr>
           <p:cNvPr id="154" name="④ 이벤트"/>
-          <p:cNvCxnSpPr>
-            <a:cxnSpLocks/>
-          </p:cNvCxnSpPr>
+          <p:cNvCxnSpPr/>
           <p:nvPr/>
         </p:nvCxnSpPr>
         <p:spPr>
           <a:xfrm flipH="1">
-            <a:off x="3800000" y="5080000"/>
-            <a:ext cx="1230000" cy="0"/>
-          </a:xfrm>
-          <a:prstGeom prst="straightConnector1">
-            <a:avLst/>
-          </a:prstGeom>
-          <a:ln>
+            <a:off x="3850000" y="4960000"/>
+            <a:ext cx="1100000" cy="0"/>
+          </a:xfrm>
+          <a:prstGeom prst="line">
+            <a:avLst/>
+          </a:prstGeom>
+          <a:ln w="12700">
             <a:solidFill>
               <a:schemeClr val="tx1"/>
             </a:solidFill>
             <a:prstDash val="dash"/>
-            <a:headEnd type="none" w="med" len="med"/>
-            <a:tailEnd type="arrow" w="med" len="med"/>
+            <a:tailEnd type="arrow"/>
           </a:ln>
         </p:spPr>
-        <p:style>
-          <a:lnRef idx="1">
-            <a:schemeClr val="accent1"/>
-          </a:lnRef>
-          <a:fillRef idx="0">
-            <a:schemeClr val="accent1"/>
-          </a:fillRef>
-          <a:effectRef idx="0">
-            <a:schemeClr val="accent1"/>
-          </a:effectRef>
-          <a:fontRef idx="minor">
-            <a:schemeClr val="tx1"/>
-          </a:fontRef>
-        </p:style>
       </p:cxnSp>
       <p:sp>
         <p:nvSpPr>
@@ -7836,8 +7922,8 @@
         </p:nvSpPr>
         <p:spPr>
           <a:xfrm>
-            <a:off x="3930000" y="4620000"/>
-            <a:ext cx="980000" cy="420000"/>
+            <a:off x="3970000" y="5000000"/>
+            <a:ext cx="860000" cy="400000"/>
           </a:xfrm>
           <a:prstGeom prst="rect">
             <a:avLst/>
@@ -7892,8 +7978,8 @@
         </p:nvSpPr>
         <p:spPr>
           <a:xfrm>
-            <a:off x="5450000" y="3160000"/>
-            <a:ext cx="1050000" cy="1240000"/>
+            <a:off x="5370000" y="3040000"/>
+            <a:ext cx="1130000" cy="1240000"/>
           </a:xfrm>
           <a:custGeom>
             <a:avLst/>
@@ -7902,7 +7988,7 @@
             <a:cxnLst/>
             <a:rect l="0" t="0" r="r" b="b"/>
             <a:pathLst>
-              <a:path w="1050000" h="1240000" fill="none">
+              <a:path w="1130000" h="1240000" fill="none">
                 <a:moveTo>
                   <a:pt x="0" y="1240000"/>
                 </a:moveTo>
@@ -7910,7 +7996,7 @@
                   <a:pt x="0" y="0"/>
                 </a:lnTo>
                 <a:lnTo>
-                  <a:pt x="1050000" y="0"/>
+                  <a:pt x="1130000" y="0"/>
                 </a:lnTo>
               </a:path>
             </a:pathLst>
@@ -7927,123 +8013,72 @@
       </p:sp>
       <p:cxnSp>
         <p:nvCxnSpPr>
-          <p:cNvPr id="157" name="Coordinator to Location Store"/>
-          <p:cNvCxnSpPr>
-            <a:cxnSpLocks/>
-          </p:cNvCxnSpPr>
+          <p:cNvPr id="157" name="Coordinator to Store"/>
+          <p:cNvCxnSpPr/>
           <p:nvPr/>
         </p:nvCxnSpPr>
         <p:spPr>
           <a:xfrm>
-            <a:off x="6280000" y="4580000"/>
-            <a:ext cx="220000" cy="0"/>
-          </a:xfrm>
-          <a:prstGeom prst="straightConnector1">
-            <a:avLst/>
-          </a:prstGeom>
-          <a:ln>
+            <a:off x="6400000" y="4460000"/>
+            <a:ext cx="100000" cy="0"/>
+          </a:xfrm>
+          <a:prstGeom prst="line">
+            <a:avLst/>
+          </a:prstGeom>
+          <a:ln w="12700">
             <a:solidFill>
               <a:schemeClr val="tx1"/>
             </a:solidFill>
             <a:prstDash val="dash"/>
-            <a:headEnd type="none" w="med" len="med"/>
-            <a:tailEnd type="arrow" w="med" len="med"/>
+            <a:tailEnd type="arrow"/>
           </a:ln>
         </p:spPr>
-        <p:style>
-          <a:lnRef idx="1">
-            <a:schemeClr val="accent1"/>
-          </a:lnRef>
-          <a:fillRef idx="0">
-            <a:schemeClr val="accent1"/>
-          </a:fillRef>
-          <a:effectRef idx="0">
-            <a:schemeClr val="accent1"/>
-          </a:effectRef>
-          <a:fontRef idx="minor">
-            <a:schemeClr val="tx1"/>
-          </a:fontRef>
-        </p:style>
       </p:cxnSp>
       <p:cxnSp>
         <p:nvCxnSpPr>
           <p:cNvPr id="158" name="Reconciler to Coordinator"/>
-          <p:cNvCxnSpPr>
-            <a:cxnSpLocks/>
-          </p:cNvCxnSpPr>
+          <p:cNvCxnSpPr/>
           <p:nvPr/>
         </p:nvCxnSpPr>
         <p:spPr>
           <a:xfrm flipV="1">
-            <a:off x="5650000" y="4760000"/>
+            <a:off x="5570000" y="4640000"/>
             <a:ext cx="0" cy="140000"/>
           </a:xfrm>
-          <a:prstGeom prst="straightConnector1">
-            <a:avLst/>
-          </a:prstGeom>
-          <a:ln>
+          <a:prstGeom prst="line">
+            <a:avLst/>
+          </a:prstGeom>
+          <a:ln w="12700">
             <a:solidFill>
               <a:schemeClr val="tx1"/>
             </a:solidFill>
             <a:prstDash val="dash"/>
-            <a:headEnd type="none" w="med" len="med"/>
-            <a:tailEnd type="arrow" w="med" len="med"/>
+            <a:tailEnd type="arrow"/>
           </a:ln>
         </p:spPr>
-        <p:style>
-          <a:lnRef idx="1">
-            <a:schemeClr val="accent1"/>
-          </a:lnRef>
-          <a:fillRef idx="0">
-            <a:schemeClr val="accent1"/>
-          </a:fillRef>
-          <a:effectRef idx="0">
-            <a:schemeClr val="accent1"/>
-          </a:effectRef>
-          <a:fontRef idx="minor">
-            <a:schemeClr val="tx1"/>
-          </a:fontRef>
-        </p:style>
       </p:cxnSp>
       <p:cxnSp>
         <p:nvCxnSpPr>
           <p:cNvPr id="159" name="① Event"/>
-          <p:cNvCxnSpPr>
-            <a:cxnSpLocks/>
-          </p:cNvCxnSpPr>
+          <p:cNvCxnSpPr/>
           <p:nvPr/>
         </p:nvCxnSpPr>
         <p:spPr>
           <a:xfrm>
-            <a:off x="1425000" y="2140000"/>
-            <a:ext cx="0" cy="360000"/>
-          </a:xfrm>
-          <a:prstGeom prst="straightConnector1">
-            <a:avLst/>
-          </a:prstGeom>
-          <a:ln>
+            <a:off x="1000000" y="1960000"/>
+            <a:ext cx="0" cy="740000"/>
+          </a:xfrm>
+          <a:prstGeom prst="line">
+            <a:avLst/>
+          </a:prstGeom>
+          <a:ln w="12700">
             <a:solidFill>
               <a:schemeClr val="tx1"/>
             </a:solidFill>
             <a:prstDash val="dash"/>
-            <a:headEnd type="none" w="med" len="med"/>
-            <a:tailEnd type="arrow" w="med" len="med"/>
+            <a:tailEnd type="arrow"/>
           </a:ln>
         </p:spPr>
-        <p:style>
-          <a:lnRef idx="1">
-            <a:schemeClr val="accent1"/>
-          </a:lnRef>
-          <a:fillRef idx="0">
-            <a:schemeClr val="accent1"/>
-          </a:fillRef>
-          <a:effectRef idx="0">
-            <a:schemeClr val="accent1"/>
-          </a:effectRef>
-          <a:fontRef idx="minor">
-            <a:schemeClr val="tx1"/>
-          </a:fontRef>
-        </p:style>
       </p:cxnSp>
       <p:sp>
         <p:nvSpPr>
@@ -8053,8 +8088,8 @@
         </p:nvSpPr>
         <p:spPr>
           <a:xfrm>
-            <a:off x="1500000" y="2200000"/>
-            <a:ext cx="2400000" cy="260000"/>
+            <a:off x="1100000" y="2040000"/>
+            <a:ext cx="2800000" cy="260000"/>
           </a:xfrm>
           <a:prstGeom prst="rect">
             <a:avLst/>
@@ -8082,42 +8117,26 @@
       <p:cxnSp>
         <p:nvCxnSpPr>
           <p:cNvPr id="161" name="⑤ Scheduler와 Control Plane"/>
-          <p:cNvCxnSpPr>
-            <a:cxnSpLocks/>
-          </p:cNvCxnSpPr>
+          <p:cNvCxnSpPr/>
           <p:nvPr/>
         </p:nvCxnSpPr>
         <p:spPr>
           <a:xfrm>
-            <a:off x="5650000" y="2140000"/>
-            <a:ext cx="0" cy="360000"/>
-          </a:xfrm>
-          <a:prstGeom prst="straightConnector1">
-            <a:avLst/>
-          </a:prstGeom>
-          <a:ln>
+            <a:off x="7600000" y="1960000"/>
+            <a:ext cx="0" cy="740000"/>
+          </a:xfrm>
+          <a:prstGeom prst="line">
+            <a:avLst/>
+          </a:prstGeom>
+          <a:ln w="12700">
             <a:solidFill>
               <a:schemeClr val="tx1"/>
             </a:solidFill>
             <a:prstDash val="dash"/>
-            <a:headEnd type="arrow" w="med" len="med"/>
-            <a:tailEnd type="arrow" w="med" len="med"/>
+            <a:headEnd type="arrow"/>
+            <a:tailEnd type="arrow"/>
           </a:ln>
         </p:spPr>
-        <p:style>
-          <a:lnRef idx="1">
-            <a:schemeClr val="accent1"/>
-          </a:lnRef>
-          <a:fillRef idx="0">
-            <a:schemeClr val="accent1"/>
-          </a:fillRef>
-          <a:effectRef idx="0">
-            <a:schemeClr val="accent1"/>
-          </a:effectRef>
-          <a:fontRef idx="minor">
-            <a:schemeClr val="tx1"/>
-          </a:fontRef>
-        </p:style>
       </p:cxnSp>
       <p:sp>
         <p:nvSpPr>
@@ -8127,8 +8146,8 @@
         </p:nvSpPr>
         <p:spPr>
           <a:xfrm>
-            <a:off x="5730000" y="2170000"/>
-            <a:ext cx="2120000" cy="300000"/>
+            <a:off x="5300000" y="2040000"/>
+            <a:ext cx="2220000" cy="260000"/>
           </a:xfrm>
           <a:prstGeom prst="rect">
             <a:avLst/>
@@ -8141,7 +8160,7 @@
           </a:bodyPr>
           <a:lstStyle/>
           <a:p>
-            <a:pPr algn="l"/>
+            <a:pPr algn="r"/>
             <a:r>
               <a:rPr lang="ko-KR" altLang="en-US" sz="700" dirty="0">
                 <a:solidFill>
@@ -8152,7 +8171,7 @@
             </a:r>
           </a:p>
           <a:p>
-            <a:pPr algn="l"/>
+            <a:pPr algn="r"/>
             <a:r>
               <a:rPr lang="ko-KR" altLang="en-US" sz="700" dirty="0">
                 <a:solidFill>
@@ -8167,17 +8186,15 @@
       <p:cxnSp>
         <p:nvCxnSpPr>
           <p:cNvPr id="163" name="⑥ command"/>
-          <p:cNvCxnSpPr>
-            <a:cxnSpLocks/>
-          </p:cNvCxnSpPr>
+          <p:cNvCxnSpPr/>
           <p:nvPr/>
         </p:nvCxnSpPr>
         <p:spPr>
           <a:xfrm>
-            <a:off x="7750000" y="3080000"/>
-            <a:ext cx="1130000" cy="0"/>
-          </a:xfrm>
-          <a:prstGeom prst="straightConnector1">
+            <a:off x="7950000" y="2960000"/>
+            <a:ext cx="900000" cy="0"/>
+          </a:xfrm>
+          <a:prstGeom prst="line">
             <a:avLst/>
           </a:prstGeom>
           <a:ln w="28575">
@@ -8185,24 +8202,9 @@
               <a:schemeClr val="tx1"/>
             </a:solidFill>
             <a:prstDash val="dash"/>
-            <a:headEnd type="none" w="med" len="med"/>
-            <a:tailEnd type="arrow" w="med" len="med"/>
+            <a:tailEnd type="arrow"/>
           </a:ln>
         </p:spPr>
-        <p:style>
-          <a:lnRef idx="1">
-            <a:schemeClr val="accent1"/>
-          </a:lnRef>
-          <a:fillRef idx="0">
-            <a:schemeClr val="accent1"/>
-          </a:fillRef>
-          <a:effectRef idx="0">
-            <a:schemeClr val="accent1"/>
-          </a:effectRef>
-          <a:fontRef idx="minor">
-            <a:schemeClr val="tx1"/>
-          </a:fontRef>
-        </p:style>
       </p:cxnSp>
       <p:sp>
         <p:nvSpPr>
@@ -8212,8 +8214,8 @@
         </p:nvSpPr>
         <p:spPr>
           <a:xfrm>
-            <a:off x="7970000" y="2720000"/>
-            <a:ext cx="660000" cy="320000"/>
+            <a:off x="8070000" y="2580000"/>
+            <a:ext cx="660000" cy="340000"/>
           </a:xfrm>
           <a:prstGeom prst="rect">
             <a:avLst/>
@@ -8233,7 +8235,7 @@
                   <a:schemeClr val="tx1"/>
                 </a:solidFill>
               </a:rPr>
-              <a:t>⑥ command ·</a:t>
+              <a:t>⑥ command</a:t>
             </a:r>
           </a:p>
           <a:p>
@@ -8244,7 +8246,7 @@
                   <a:schemeClr val="tx1"/>
                 </a:solidFill>
               </a:rPr>
-              <a:t>dependency</a:t>
+              <a:t>· dependency</a:t>
             </a:r>
           </a:p>
         </p:txBody>
@@ -8257,8 +8259,8 @@
         </p:nvSpPr>
         <p:spPr>
           <a:xfrm>
-            <a:off x="6280000" y="3260000"/>
-            <a:ext cx="2770000" cy="1820000"/>
+            <a:off x="6400000" y="3140000"/>
+            <a:ext cx="2650000" cy="1820000"/>
           </a:xfrm>
           <a:custGeom>
             <a:avLst/>
@@ -8267,12 +8269,12 @@
             <a:cxnLst/>
             <a:rect l="0" t="0" r="r" b="b"/>
             <a:pathLst>
-              <a:path w="2770000" h="1820000" fill="none">
+              <a:path w="2650000" h="1820000" fill="none">
                 <a:moveTo>
-                  <a:pt x="2770000" y="0"/>
+                  <a:pt x="2650000" y="0"/>
                 </a:moveTo>
                 <a:lnTo>
-                  <a:pt x="2770000" y="1820000"/>
+                  <a:pt x="2650000" y="1820000"/>
                 </a:lnTo>
                 <a:lnTo>
                   <a:pt x="0" y="1820000"/>
@@ -8298,8 +8300,8 @@
         </p:nvSpPr>
         <p:spPr>
           <a:xfrm>
-            <a:off x="6550000" y="4840000"/>
-            <a:ext cx="1250000" cy="180000"/>
+            <a:off x="6550000" y="4720000"/>
+            <a:ext cx="2050000" cy="180000"/>
           </a:xfrm>
           <a:prstGeom prst="rect">
             <a:avLst/>
@@ -8327,42 +8329,26 @@
       <p:cxnSp>
         <p:nvCxnSpPr>
           <p:cNvPr id="167" name="⑧ dependency 대기"/>
-          <p:cNvCxnSpPr>
-            <a:cxnSpLocks/>
-          </p:cNvCxnSpPr>
+          <p:cNvCxnSpPr/>
           <p:nvPr/>
         </p:nvCxnSpPr>
         <p:spPr>
           <a:xfrm flipV="1">
-            <a:off x="11350000" y="2140000"/>
-            <a:ext cx="0" cy="760000"/>
-          </a:xfrm>
-          <a:prstGeom prst="straightConnector1">
-            <a:avLst/>
-          </a:prstGeom>
-          <a:ln>
+            <a:off x="11500000" y="1960000"/>
+            <a:ext cx="0" cy="820000"/>
+          </a:xfrm>
+          <a:prstGeom prst="line">
+            <a:avLst/>
+          </a:prstGeom>
+          <a:ln w="12700">
             <a:solidFill>
               <a:schemeClr val="tx1"/>
             </a:solidFill>
             <a:prstDash val="dash"/>
-            <a:headEnd type="arrow" w="med" len="med"/>
-            <a:tailEnd type="arrow" w="med" len="med"/>
+            <a:headEnd type="arrow"/>
+            <a:tailEnd type="arrow"/>
           </a:ln>
         </p:spPr>
-        <p:style>
-          <a:lnRef idx="1">
-            <a:schemeClr val="accent1"/>
-          </a:lnRef>
-          <a:fillRef idx="0">
-            <a:schemeClr val="accent1"/>
-          </a:fillRef>
-          <a:effectRef idx="0">
-            <a:schemeClr val="accent1"/>
-          </a:effectRef>
-          <a:fontRef idx="minor">
-            <a:schemeClr val="tx1"/>
-          </a:fontRef>
-        </p:style>
       </p:cxnSp>
       <p:sp>
         <p:nvSpPr>
@@ -8372,8 +8358,8 @@
         </p:nvSpPr>
         <p:spPr>
           <a:xfrm>
-            <a:off x="9200000" y="2220000"/>
-            <a:ext cx="2100000" cy="240000"/>
+            <a:off x="9050000" y="2060000"/>
+            <a:ext cx="2250000" cy="220000"/>
           </a:xfrm>
           <a:prstGeom prst="rect">
             <a:avLst/>
@@ -8401,93 +8387,127 @@
       <p:cxnSp>
         <p:nvCxnSpPr>
           <p:cNvPr id="169" name="Executor to Router"/>
-          <p:cNvCxnSpPr>
-            <a:cxnSpLocks/>
-          </p:cNvCxnSpPr>
+          <p:cNvCxnSpPr/>
           <p:nvPr/>
         </p:nvCxnSpPr>
         <p:spPr>
           <a:xfrm>
-            <a:off x="10795000" y="3260000"/>
+            <a:off x="10870000" y="3140000"/>
             <a:ext cx="0" cy="640000"/>
           </a:xfrm>
-          <a:prstGeom prst="straightConnector1">
-            <a:avLst/>
-          </a:prstGeom>
-          <a:ln>
+          <a:prstGeom prst="line">
+            <a:avLst/>
+          </a:prstGeom>
+          <a:ln w="12700">
             <a:solidFill>
               <a:schemeClr val="tx1"/>
             </a:solidFill>
             <a:prstDash val="dash"/>
-            <a:headEnd type="none" w="med" len="med"/>
-            <a:tailEnd type="arrow" w="med" len="med"/>
+            <a:tailEnd type="arrow"/>
           </a:ln>
         </p:spPr>
-        <p:style>
-          <a:lnRef idx="1">
-            <a:schemeClr val="accent1"/>
-          </a:lnRef>
-          <a:fillRef idx="0">
-            <a:schemeClr val="accent1"/>
-          </a:fillRef>
-          <a:effectRef idx="0">
-            <a:schemeClr val="accent1"/>
-          </a:effectRef>
-          <a:fontRef idx="minor">
-            <a:schemeClr val="tx1"/>
-          </a:fontRef>
-        </p:style>
       </p:cxnSp>
       <p:cxnSp>
         <p:nvCxnSpPr>
-          <p:cNvPr id="170" name="⑩ Backend I/F"/>
-          <p:cNvCxnSpPr>
-            <a:cxnSpLocks/>
-          </p:cNvCxnSpPr>
+          <p:cNvPr id="170" name="⑨ 전송 실행"/>
+          <p:cNvCxnSpPr/>
           <p:nvPr/>
         </p:nvCxnSpPr>
         <p:spPr>
           <a:xfrm>
-            <a:off x="2225000" y="5400000"/>
-            <a:ext cx="0" cy="400000"/>
-          </a:xfrm>
-          <a:prstGeom prst="straightConnector1">
-            <a:avLst/>
-          </a:prstGeom>
-          <a:ln>
+            <a:off x="10870000" y="4140000"/>
+            <a:ext cx="0" cy="1660000"/>
+          </a:xfrm>
+          <a:prstGeom prst="line">
+            <a:avLst/>
+          </a:prstGeom>
+          <a:ln w="12700">
             <a:solidFill>
               <a:schemeClr val="tx1"/>
             </a:solidFill>
             <a:prstDash val="dash"/>
-            <a:headEnd type="none" w="med" len="med"/>
-            <a:tailEnd type="arrow" w="med" len="med"/>
+            <a:tailEnd type="arrow"/>
           </a:ln>
         </p:spPr>
-        <p:style>
-          <a:lnRef idx="1">
-            <a:schemeClr val="accent1"/>
-          </a:lnRef>
-          <a:fillRef idx="0">
-            <a:schemeClr val="accent1"/>
-          </a:fillRef>
-          <a:effectRef idx="0">
-            <a:schemeClr val="accent1"/>
-          </a:effectRef>
-          <a:fontRef idx="minor">
-            <a:schemeClr val="tx1"/>
-          </a:fontRef>
-        </p:style>
       </p:cxnSp>
       <p:sp>
         <p:nvSpPr>
-          <p:cNvPr id="171" name="⑩ label"/>
+          <p:cNvPr id="171" name="⑨ label"/>
           <p:cNvSpPr txBox="1"/>
           <p:nvPr/>
         </p:nvSpPr>
         <p:spPr>
           <a:xfrm>
-            <a:off x="2330000" y="5500000"/>
-            <a:ext cx="3600000" cy="200000"/>
+            <a:off x="10950000" y="4700000"/>
+            <a:ext cx="800000" cy="300000"/>
+          </a:xfrm>
+          <a:prstGeom prst="rect">
+            <a:avLst/>
+          </a:prstGeom>
+          <a:noFill/>
+        </p:spPr>
+        <p:txBody>
+          <a:bodyPr wrap="square" lIns="0" tIns="0" rIns="0" bIns="0" rtlCol="0" anchor="ctr">
+            <a:noAutofit/>
+          </a:bodyPr>
+          <a:lstStyle/>
+          <a:p>
+            <a:pPr algn="l"/>
+            <a:r>
+              <a:rPr lang="ko-KR" altLang="en-US" sz="750" dirty="0">
+                <a:solidFill>
+                  <a:schemeClr val="tx1"/>
+                </a:solidFill>
+              </a:rPr>
+              <a:t>⑨ 전송</a:t>
+            </a:r>
+          </a:p>
+          <a:p>
+            <a:pPr algn="l"/>
+            <a:r>
+              <a:rPr lang="ko-KR" altLang="en-US" sz="750" dirty="0">
+                <a:solidFill>
+                  <a:schemeClr val="tx1"/>
+                </a:solidFill>
+              </a:rPr>
+              <a:t>실행</a:t>
+            </a:r>
+          </a:p>
+        </p:txBody>
+      </p:sp>
+      <p:cxnSp>
+        <p:nvCxnSpPr>
+          <p:cNvPr id="172" name="⑩ Backend I/F"/>
+          <p:cNvCxnSpPr/>
+          <p:nvPr/>
+        </p:nvCxnSpPr>
+        <p:spPr>
+          <a:xfrm>
+            <a:off x="2250000" y="5310000"/>
+            <a:ext cx="0" cy="490000"/>
+          </a:xfrm>
+          <a:prstGeom prst="line">
+            <a:avLst/>
+          </a:prstGeom>
+          <a:ln w="12700">
+            <a:solidFill>
+              <a:schemeClr val="tx1"/>
+            </a:solidFill>
+            <a:prstDash val="dash"/>
+            <a:tailEnd type="arrow"/>
+          </a:ln>
+        </p:spPr>
+      </p:cxnSp>
+      <p:sp>
+        <p:nvSpPr>
+          <p:cNvPr id="173" name="⑩ label"/>
+          <p:cNvSpPr txBox="1"/>
+          <p:nvPr/>
+        </p:nvSpPr>
+        <p:spPr>
+          <a:xfrm>
+            <a:off x="2330000" y="5450000"/>
+            <a:ext cx="3400000" cy="200000"/>
           </a:xfrm>
           <a:prstGeom prst="rect">
             <a:avLst/>
@@ -8514,128 +8534,26 @@
       </p:sp>
       <p:cxnSp>
         <p:nvCxnSpPr>
-          <p:cNvPr id="172" name="⑨ 전송 실행"/>
-          <p:cNvCxnSpPr>
-            <a:cxnSpLocks/>
-          </p:cNvCxnSpPr>
+          <p:cNvPr id="174" name="⑪ staging"/>
+          <p:cNvCxnSpPr/>
           <p:nvPr/>
         </p:nvCxnSpPr>
         <p:spPr>
-          <a:xfrm>
-            <a:off x="10795000" y="4260000"/>
-            <a:ext cx="0" cy="1540000"/>
-          </a:xfrm>
-          <a:prstGeom prst="straightConnector1">
-            <a:avLst/>
-          </a:prstGeom>
-          <a:ln>
+          <a:xfrm flipH="1">
+            <a:off x="6500000" y="6220000"/>
+            <a:ext cx="2350000" cy="0"/>
+          </a:xfrm>
+          <a:prstGeom prst="line">
+            <a:avLst/>
+          </a:prstGeom>
+          <a:ln w="12700">
             <a:solidFill>
               <a:schemeClr val="tx1"/>
             </a:solidFill>
             <a:prstDash val="dash"/>
-            <a:headEnd type="none" w="med" len="med"/>
-            <a:tailEnd type="arrow" w="med" len="med"/>
+            <a:tailEnd type="arrow"/>
           </a:ln>
         </p:spPr>
-        <p:style>
-          <a:lnRef idx="1">
-            <a:schemeClr val="accent1"/>
-          </a:lnRef>
-          <a:fillRef idx="0">
-            <a:schemeClr val="accent1"/>
-          </a:fillRef>
-          <a:effectRef idx="0">
-            <a:schemeClr val="accent1"/>
-          </a:effectRef>
-          <a:fontRef idx="minor">
-            <a:schemeClr val="tx1"/>
-          </a:fontRef>
-        </p:style>
-      </p:cxnSp>
-      <p:sp>
-        <p:nvSpPr>
-          <p:cNvPr id="173" name="⑨ label"/>
-          <p:cNvSpPr txBox="1"/>
-          <p:nvPr/>
-        </p:nvSpPr>
-        <p:spPr>
-          <a:xfrm>
-            <a:off x="10890000" y="4550000"/>
-            <a:ext cx="800000" cy="300000"/>
-          </a:xfrm>
-          <a:prstGeom prst="rect">
-            <a:avLst/>
-          </a:prstGeom>
-          <a:noFill/>
-        </p:spPr>
-        <p:txBody>
-          <a:bodyPr wrap="square" lIns="0" tIns="0" rIns="0" bIns="0" rtlCol="0" anchor="ctr">
-            <a:noAutofit/>
-          </a:bodyPr>
-          <a:lstStyle/>
-          <a:p>
-            <a:pPr algn="l"/>
-            <a:r>
-              <a:rPr lang="ko-KR" altLang="en-US" sz="750" dirty="0">
-                <a:solidFill>
-                  <a:schemeClr val="tx1"/>
-                </a:solidFill>
-              </a:rPr>
-              <a:t>⑨ 전송</a:t>
-            </a:r>
-          </a:p>
-          <a:p>
-            <a:pPr algn="l"/>
-            <a:r>
-              <a:rPr lang="ko-KR" altLang="en-US" sz="750" dirty="0">
-                <a:solidFill>
-                  <a:schemeClr val="tx1"/>
-                </a:solidFill>
-              </a:rPr>
-              <a:t>실행</a:t>
-            </a:r>
-          </a:p>
-        </p:txBody>
-      </p:sp>
-      <p:cxnSp>
-        <p:nvCxnSpPr>
-          <p:cNvPr id="174" name="⑪ staging"/>
-          <p:cNvCxnSpPr>
-            <a:cxnSpLocks/>
-          </p:cNvCxnSpPr>
-          <p:nvPr/>
-        </p:nvCxnSpPr>
-        <p:spPr>
-          <a:xfrm flipH="1">
-            <a:off x="6500000" y="6225000"/>
-            <a:ext cx="2380000" cy="0"/>
-          </a:xfrm>
-          <a:prstGeom prst="straightConnector1">
-            <a:avLst/>
-          </a:prstGeom>
-          <a:ln>
-            <a:solidFill>
-              <a:schemeClr val="tx1"/>
-            </a:solidFill>
-            <a:prstDash val="dash"/>
-            <a:headEnd type="none" w="med" len="med"/>
-            <a:tailEnd type="arrow" w="med" len="med"/>
-          </a:ln>
-        </p:spPr>
-        <p:style>
-          <a:lnRef idx="1">
-            <a:schemeClr val="accent1"/>
-          </a:lnRef>
-          <a:fillRef idx="0">
-            <a:schemeClr val="accent1"/>
-          </a:fillRef>
-          <a:effectRef idx="0">
-            <a:schemeClr val="accent1"/>
-          </a:effectRef>
-          <a:fontRef idx="minor">
-            <a:schemeClr val="tx1"/>
-          </a:fontRef>
-        </p:style>
       </p:cxnSp>
       <p:sp>
         <p:nvSpPr>
@@ -8645,8 +8563,8 @@
         </p:nvSpPr>
         <p:spPr>
           <a:xfrm>
-            <a:off x="6550000" y="5980000"/>
-            <a:ext cx="2300000" cy="200000"/>
+            <a:off x="6550000" y="5950000"/>
+            <a:ext cx="2100000" cy="200000"/>
           </a:xfrm>
           <a:prstGeom prst="rect">
             <a:avLst/>

</xml_diff>